<commit_message>
Series A deck: apply authoritative brand palette (v3)
Reconciled to the official TrialScreen Brand Guidelines v250728:
- Body text and dark-slide backgrounds use Ink #2F3241 (was #1A1A2E)
- Magenta accent corrected to Hero Pink #C43C96 (was #C22299)
- Hero Purple #773A96 preserved for headings and rules
- Added Logo Purple #62317D as a registered constant
- Added one subtle Mustard #FFB01A underscore beneath the $138 hero
  (slide 12) and $5M hero (slide 20) as a Client-palette accent

Content and editorial layout (25 slides, shapes A-J) are unchanged.
Previous v2-editorial archived.
</commit_message>
<xml_diff>
--- a/documents/TrialScreen_SeriesA_Deck.pptx
+++ b/documents/TrialScreen_SeriesA_Deck.pptx
@@ -2993,7 +2993,7 @@
     <p:bg>
       <p:bgPr>
         <a:solidFill>
-          <a:srgbClr val="1A1A2E"/>
+          <a:srgbClr val="2F3241"/>
         </a:solidFill>
       </p:bgPr>
     </p:bg>
@@ -3405,7 +3405,7 @@
             <a:r>
               <a:rPr lang="en-US" sz="2800" b="1" spc="-50" kern="0" dirty="0">
                 <a:solidFill>
-                  <a:srgbClr val="1A1A2E"/>
+                  <a:srgbClr val="2F3241"/>
                 </a:solidFill>
                 <a:latin typeface="Trebuchet MS" pitchFamily="34" charset="0"/>
                 <a:ea typeface="Trebuchet MS" pitchFamily="34" charset="-122"/>
@@ -3483,7 +3483,7 @@
             <a:r>
               <a:rPr lang="en-US" sz="1800" b="1" dirty="0">
                 <a:solidFill>
-                  <a:srgbClr val="1A1A2E"/>
+                  <a:srgbClr val="2F3241"/>
                 </a:solidFill>
                 <a:latin typeface="Trebuchet MS" pitchFamily="34" charset="0"/>
                 <a:ea typeface="Trebuchet MS" pitchFamily="34" charset="-122"/>
@@ -3525,7 +3525,7 @@
             <a:r>
               <a:rPr lang="en-US" sz="1200" dirty="0">
                 <a:solidFill>
-                  <a:srgbClr val="1A1A2E"/>
+                  <a:srgbClr val="2F3241"/>
                 </a:solidFill>
                 <a:latin typeface="Calibri" pitchFamily="34" charset="0"/>
                 <a:ea typeface="Calibri" pitchFamily="34" charset="-122"/>
@@ -3626,7 +3626,7 @@
             <a:r>
               <a:rPr lang="en-US" sz="1800" b="1" dirty="0">
                 <a:solidFill>
-                  <a:srgbClr val="1A1A2E"/>
+                  <a:srgbClr val="2F3241"/>
                 </a:solidFill>
                 <a:latin typeface="Trebuchet MS" pitchFamily="34" charset="0"/>
                 <a:ea typeface="Trebuchet MS" pitchFamily="34" charset="-122"/>
@@ -3668,7 +3668,7 @@
             <a:r>
               <a:rPr lang="en-US" sz="1200" dirty="0">
                 <a:solidFill>
-                  <a:srgbClr val="1A1A2E"/>
+                  <a:srgbClr val="2F3241"/>
                 </a:solidFill>
                 <a:latin typeface="Calibri" pitchFamily="34" charset="0"/>
                 <a:ea typeface="Calibri" pitchFamily="34" charset="-122"/>
@@ -3730,7 +3730,7 @@
             <a:r>
               <a:rPr lang="en-US" sz="900" b="1" spc="300" kern="0" dirty="0">
                 <a:solidFill>
-                  <a:srgbClr val="C22299"/>
+                  <a:srgbClr val="C43C96"/>
                 </a:solidFill>
                 <a:latin typeface="Calibri" pitchFamily="34" charset="0"/>
                 <a:ea typeface="Calibri" pitchFamily="34" charset="-122"/>
@@ -3769,7 +3769,7 @@
             <a:r>
               <a:rPr lang="en-US" sz="1800" b="1" dirty="0">
                 <a:solidFill>
-                  <a:srgbClr val="1A1A2E"/>
+                  <a:srgbClr val="2F3241"/>
                 </a:solidFill>
                 <a:latin typeface="Trebuchet MS" pitchFamily="34" charset="0"/>
                 <a:ea typeface="Trebuchet MS" pitchFamily="34" charset="-122"/>
@@ -3811,7 +3811,7 @@
             <a:r>
               <a:rPr lang="en-US" sz="1200" dirty="0">
                 <a:solidFill>
-                  <a:srgbClr val="1A1A2E"/>
+                  <a:srgbClr val="2F3241"/>
                 </a:solidFill>
                 <a:latin typeface="Calibri" pitchFamily="34" charset="0"/>
                 <a:ea typeface="Calibri" pitchFamily="34" charset="-122"/>
@@ -4044,7 +4044,7 @@
             <a:r>
               <a:rPr lang="en-US" sz="1700" b="1" dirty="0">
                 <a:solidFill>
-                  <a:srgbClr val="1A1A2E"/>
+                  <a:srgbClr val="2F3241"/>
                 </a:solidFill>
                 <a:latin typeface="Calibri" pitchFamily="34" charset="0"/>
                 <a:ea typeface="Calibri" pitchFamily="34" charset="-122"/>
@@ -4078,7 +4078,7 @@
             <a:r>
               <a:rPr lang="en-US" sz="1700" dirty="0">
                 <a:solidFill>
-                  <a:srgbClr val="1A1A2E"/>
+                  <a:srgbClr val="2F3241"/>
                 </a:solidFill>
                 <a:latin typeface="Calibri" pitchFamily="34" charset="0"/>
                 <a:ea typeface="Calibri" pitchFamily="34" charset="-122"/>
@@ -4112,7 +4112,7 @@
             <a:r>
               <a:rPr lang="en-US" sz="1700" dirty="0">
                 <a:solidFill>
-                  <a:srgbClr val="1A1A2E"/>
+                  <a:srgbClr val="2F3241"/>
                 </a:solidFill>
                 <a:latin typeface="Calibri" pitchFamily="34" charset="0"/>
                 <a:ea typeface="Calibri" pitchFamily="34" charset="-122"/>
@@ -4146,7 +4146,7 @@
             <a:r>
               <a:rPr lang="en-US" sz="1700" dirty="0">
                 <a:solidFill>
-                  <a:srgbClr val="1A1A2E"/>
+                  <a:srgbClr val="2F3241"/>
                 </a:solidFill>
                 <a:latin typeface="Calibri" pitchFamily="34" charset="0"/>
                 <a:ea typeface="Calibri" pitchFamily="34" charset="-122"/>
@@ -4180,7 +4180,7 @@
             <a:r>
               <a:rPr lang="en-US" sz="1700" dirty="0">
                 <a:solidFill>
-                  <a:srgbClr val="1A1A2E"/>
+                  <a:srgbClr val="2F3241"/>
                 </a:solidFill>
                 <a:latin typeface="Calibri" pitchFamily="34" charset="0"/>
                 <a:ea typeface="Calibri" pitchFamily="34" charset="-122"/>
@@ -4214,7 +4214,7 @@
             <a:r>
               <a:rPr lang="en-US" sz="1700" dirty="0">
                 <a:solidFill>
-                  <a:srgbClr val="1A1A2E"/>
+                  <a:srgbClr val="2F3241"/>
                 </a:solidFill>
                 <a:latin typeface="Calibri" pitchFamily="34" charset="0"/>
                 <a:ea typeface="Calibri" pitchFamily="34" charset="-122"/>
@@ -4248,7 +4248,7 @@
             <a:r>
               <a:rPr lang="en-US" sz="1700" dirty="0">
                 <a:solidFill>
-                  <a:srgbClr val="1A1A2E"/>
+                  <a:srgbClr val="2F3241"/>
                 </a:solidFill>
                 <a:latin typeface="Calibri" pitchFamily="34" charset="0"/>
                 <a:ea typeface="Calibri" pitchFamily="34" charset="-122"/>
@@ -4329,7 +4329,7 @@
             <a:r>
               <a:rPr lang="en-US" sz="1300" dirty="0">
                 <a:solidFill>
-                  <a:srgbClr val="1A1A2E"/>
+                  <a:srgbClr val="2F3241"/>
                 </a:solidFill>
                 <a:latin typeface="Calibri" pitchFamily="34" charset="0"/>
                 <a:ea typeface="Calibri" pitchFamily="34" charset="-122"/>
@@ -4556,7 +4556,7 @@
             <a:r>
               <a:rPr lang="en-US" sz="17000" b="1" spc="-600" kern="0" dirty="0">
                 <a:solidFill>
-                  <a:srgbClr val="1A1A2E"/>
+                  <a:srgbClr val="2F3241"/>
                 </a:solidFill>
                 <a:latin typeface="Trebuchet MS" pitchFamily="34" charset="0"/>
                 <a:ea typeface="Trebuchet MS" pitchFamily="34" charset="-122"/>
@@ -4570,7 +4570,30 @@
       </p:sp>
       <p:sp>
         <p:nvSpPr>
-          <p:cNvPr id="5" name="Text 3"/>
+          <p:cNvPr id="5" name="Shape 3"/>
+          <p:cNvSpPr/>
+          <p:nvPr/>
+        </p:nvSpPr>
+        <p:spPr>
+          <a:xfrm>
+            <a:off x="640080" y="3456432"/>
+            <a:ext cx="1280160" cy="0"/>
+          </a:xfrm>
+          <a:prstGeom prst="line">
+            <a:avLst/>
+          </a:prstGeom>
+          <a:noFill/>
+          <a:ln w="28575">
+            <a:solidFill>
+              <a:srgbClr val="FFB01A"/>
+            </a:solidFill>
+            <a:prstDash val="solid"/>
+          </a:ln>
+        </p:spPr>
+      </p:sp>
+      <p:sp>
+        <p:nvSpPr>
+          <p:cNvPr id="6" name="Text 4"/>
           <p:cNvSpPr/>
           <p:nvPr/>
         </p:nvSpPr>
@@ -4609,7 +4632,7 @@
       </p:sp>
       <p:sp>
         <p:nvSpPr>
-          <p:cNvPr id="6" name="Text 4"/>
+          <p:cNvPr id="7" name="Text 5"/>
           <p:cNvSpPr/>
           <p:nvPr/>
         </p:nvSpPr>
@@ -4648,7 +4671,7 @@
       </p:sp>
       <p:sp>
         <p:nvSpPr>
-          <p:cNvPr id="7" name="Text 5"/>
+          <p:cNvPr id="8" name="Text 6"/>
           <p:cNvSpPr/>
           <p:nvPr/>
         </p:nvSpPr>
@@ -4687,7 +4710,7 @@
       </p:sp>
       <p:sp>
         <p:nvSpPr>
-          <p:cNvPr id="8" name="Text 6"/>
+          <p:cNvPr id="9" name="Text 7"/>
           <p:cNvSpPr/>
           <p:nvPr/>
         </p:nvSpPr>
@@ -4726,7 +4749,7 @@
       </p:sp>
       <p:sp>
         <p:nvSpPr>
-          <p:cNvPr id="9" name="Text 7"/>
+          <p:cNvPr id="10" name="Text 8"/>
           <p:cNvSpPr/>
           <p:nvPr/>
         </p:nvSpPr>
@@ -4765,7 +4788,7 @@
       </p:sp>
       <p:sp>
         <p:nvSpPr>
-          <p:cNvPr id="10" name="Shape 8"/>
+          <p:cNvPr id="11" name="Shape 9"/>
           <p:cNvSpPr/>
           <p:nvPr/>
         </p:nvSpPr>
@@ -4788,7 +4811,7 @@
       </p:sp>
       <p:sp>
         <p:nvSpPr>
-          <p:cNvPr id="11" name="Text 9"/>
+          <p:cNvPr id="12" name="Text 10"/>
           <p:cNvSpPr/>
           <p:nvPr/>
         </p:nvSpPr>
@@ -4813,7 +4836,7 @@
             <a:r>
               <a:rPr lang="en-US" sz="1200" b="1" dirty="0">
                 <a:solidFill>
-                  <a:srgbClr val="1A1A2E"/>
+                  <a:srgbClr val="2F3241"/>
                 </a:solidFill>
                 <a:latin typeface="Calibri" pitchFamily="34" charset="0"/>
                 <a:ea typeface="Calibri" pitchFamily="34" charset="-122"/>
@@ -4827,7 +4850,7 @@
       </p:sp>
       <p:sp>
         <p:nvSpPr>
-          <p:cNvPr id="12" name="Text 10"/>
+          <p:cNvPr id="13" name="Text 11"/>
           <p:cNvSpPr/>
           <p:nvPr/>
         </p:nvSpPr>
@@ -4852,7 +4875,7 @@
             <a:r>
               <a:rPr lang="en-US" sz="1200" dirty="0">
                 <a:solidFill>
-                  <a:srgbClr val="1A1A2E"/>
+                  <a:srgbClr val="2F3241"/>
                 </a:solidFill>
                 <a:latin typeface="Calibri" pitchFamily="34" charset="0"/>
                 <a:ea typeface="Calibri" pitchFamily="34" charset="-122"/>
@@ -4866,7 +4889,7 @@
       </p:sp>
       <p:sp>
         <p:nvSpPr>
-          <p:cNvPr id="13" name="Text 11"/>
+          <p:cNvPr id="14" name="Text 12"/>
           <p:cNvSpPr/>
           <p:nvPr/>
         </p:nvSpPr>
@@ -4891,7 +4914,7 @@
             <a:r>
               <a:rPr lang="en-US" sz="1200" dirty="0">
                 <a:solidFill>
-                  <a:srgbClr val="1A1A2E"/>
+                  <a:srgbClr val="2F3241"/>
                 </a:solidFill>
                 <a:latin typeface="Calibri" pitchFamily="34" charset="0"/>
                 <a:ea typeface="Calibri" pitchFamily="34" charset="-122"/>
@@ -4905,7 +4928,7 @@
       </p:sp>
       <p:sp>
         <p:nvSpPr>
-          <p:cNvPr id="14" name="Text 12"/>
+          <p:cNvPr id="15" name="Text 13"/>
           <p:cNvSpPr/>
           <p:nvPr/>
         </p:nvSpPr>
@@ -4930,7 +4953,7 @@
             <a:r>
               <a:rPr lang="en-US" sz="1200" dirty="0">
                 <a:solidFill>
-                  <a:srgbClr val="1A1A2E"/>
+                  <a:srgbClr val="2F3241"/>
                 </a:solidFill>
                 <a:latin typeface="Calibri" pitchFamily="34" charset="0"/>
                 <a:ea typeface="Calibri" pitchFamily="34" charset="-122"/>
@@ -4944,7 +4967,7 @@
       </p:sp>
       <p:sp>
         <p:nvSpPr>
-          <p:cNvPr id="15" name="Shape 13"/>
+          <p:cNvPr id="16" name="Shape 14"/>
           <p:cNvSpPr/>
           <p:nvPr/>
         </p:nvSpPr>
@@ -4967,7 +4990,7 @@
       </p:sp>
       <p:sp>
         <p:nvSpPr>
-          <p:cNvPr id="16" name="Text 14"/>
+          <p:cNvPr id="17" name="Text 15"/>
           <p:cNvSpPr/>
           <p:nvPr/>
         </p:nvSpPr>
@@ -4992,7 +5015,7 @@
             <a:r>
               <a:rPr lang="en-US" sz="1200" b="1" dirty="0">
                 <a:solidFill>
-                  <a:srgbClr val="1A1A2E"/>
+                  <a:srgbClr val="2F3241"/>
                 </a:solidFill>
                 <a:latin typeface="Calibri" pitchFamily="34" charset="0"/>
                 <a:ea typeface="Calibri" pitchFamily="34" charset="-122"/>
@@ -5006,7 +5029,7 @@
       </p:sp>
       <p:sp>
         <p:nvSpPr>
-          <p:cNvPr id="17" name="Text 15"/>
+          <p:cNvPr id="18" name="Text 16"/>
           <p:cNvSpPr/>
           <p:nvPr/>
         </p:nvSpPr>
@@ -5031,7 +5054,7 @@
             <a:r>
               <a:rPr lang="en-US" sz="1200" dirty="0">
                 <a:solidFill>
-                  <a:srgbClr val="1A1A2E"/>
+                  <a:srgbClr val="2F3241"/>
                 </a:solidFill>
                 <a:latin typeface="Calibri" pitchFamily="34" charset="0"/>
                 <a:ea typeface="Calibri" pitchFamily="34" charset="-122"/>
@@ -5045,7 +5068,7 @@
       </p:sp>
       <p:sp>
         <p:nvSpPr>
-          <p:cNvPr id="18" name="Text 16"/>
+          <p:cNvPr id="19" name="Text 17"/>
           <p:cNvSpPr/>
           <p:nvPr/>
         </p:nvSpPr>
@@ -5070,7 +5093,7 @@
             <a:r>
               <a:rPr lang="en-US" sz="1200" dirty="0">
                 <a:solidFill>
-                  <a:srgbClr val="1A1A2E"/>
+                  <a:srgbClr val="2F3241"/>
                 </a:solidFill>
                 <a:latin typeface="Calibri" pitchFamily="34" charset="0"/>
                 <a:ea typeface="Calibri" pitchFamily="34" charset="-122"/>
@@ -5084,7 +5107,7 @@
       </p:sp>
       <p:sp>
         <p:nvSpPr>
-          <p:cNvPr id="19" name="Text 17"/>
+          <p:cNvPr id="20" name="Text 18"/>
           <p:cNvSpPr/>
           <p:nvPr/>
         </p:nvSpPr>
@@ -5109,7 +5132,7 @@
             <a:r>
               <a:rPr lang="en-US" sz="1200" dirty="0">
                 <a:solidFill>
-                  <a:srgbClr val="1A1A2E"/>
+                  <a:srgbClr val="2F3241"/>
                 </a:solidFill>
                 <a:latin typeface="Calibri" pitchFamily="34" charset="0"/>
                 <a:ea typeface="Calibri" pitchFamily="34" charset="-122"/>
@@ -5123,7 +5146,7 @@
       </p:sp>
       <p:sp>
         <p:nvSpPr>
-          <p:cNvPr id="20" name="Shape 18"/>
+          <p:cNvPr id="21" name="Shape 19"/>
           <p:cNvSpPr/>
           <p:nvPr/>
         </p:nvSpPr>
@@ -5146,7 +5169,7 @@
       </p:sp>
       <p:sp>
         <p:nvSpPr>
-          <p:cNvPr id="21" name="Text 19"/>
+          <p:cNvPr id="22" name="Text 20"/>
           <p:cNvSpPr/>
           <p:nvPr/>
         </p:nvSpPr>
@@ -5171,7 +5194,7 @@
             <a:r>
               <a:rPr lang="en-US" sz="1200" b="1" dirty="0">
                 <a:solidFill>
-                  <a:srgbClr val="1A1A2E"/>
+                  <a:srgbClr val="2F3241"/>
                 </a:solidFill>
                 <a:latin typeface="Calibri" pitchFamily="34" charset="0"/>
                 <a:ea typeface="Calibri" pitchFamily="34" charset="-122"/>
@@ -5185,7 +5208,7 @@
       </p:sp>
       <p:sp>
         <p:nvSpPr>
-          <p:cNvPr id="22" name="Text 20"/>
+          <p:cNvPr id="23" name="Text 21"/>
           <p:cNvSpPr/>
           <p:nvPr/>
         </p:nvSpPr>
@@ -5210,7 +5233,7 @@
             <a:r>
               <a:rPr lang="en-US" sz="1200" dirty="0">
                 <a:solidFill>
-                  <a:srgbClr val="1A1A2E"/>
+                  <a:srgbClr val="2F3241"/>
                 </a:solidFill>
                 <a:latin typeface="Calibri" pitchFamily="34" charset="0"/>
                 <a:ea typeface="Calibri" pitchFamily="34" charset="-122"/>
@@ -5224,7 +5247,7 @@
       </p:sp>
       <p:sp>
         <p:nvSpPr>
-          <p:cNvPr id="23" name="Text 21"/>
+          <p:cNvPr id="24" name="Text 22"/>
           <p:cNvSpPr/>
           <p:nvPr/>
         </p:nvSpPr>
@@ -5249,7 +5272,7 @@
             <a:r>
               <a:rPr lang="en-US" sz="1200" dirty="0">
                 <a:solidFill>
-                  <a:srgbClr val="1A1A2E"/>
+                  <a:srgbClr val="2F3241"/>
                 </a:solidFill>
                 <a:latin typeface="Calibri" pitchFamily="34" charset="0"/>
                 <a:ea typeface="Calibri" pitchFamily="34" charset="-122"/>
@@ -5263,7 +5286,7 @@
       </p:sp>
       <p:sp>
         <p:nvSpPr>
-          <p:cNvPr id="24" name="Text 22"/>
+          <p:cNvPr id="25" name="Text 23"/>
           <p:cNvSpPr/>
           <p:nvPr/>
         </p:nvSpPr>
@@ -5288,7 +5311,7 @@
             <a:r>
               <a:rPr lang="en-US" sz="1200" dirty="0">
                 <a:solidFill>
-                  <a:srgbClr val="1A1A2E"/>
+                  <a:srgbClr val="2F3241"/>
                 </a:solidFill>
                 <a:latin typeface="Calibri" pitchFamily="34" charset="0"/>
                 <a:ea typeface="Calibri" pitchFamily="34" charset="-122"/>
@@ -5302,7 +5325,7 @@
       </p:sp>
       <p:sp>
         <p:nvSpPr>
-          <p:cNvPr id="25" name="Shape 23"/>
+          <p:cNvPr id="26" name="Shape 24"/>
           <p:cNvSpPr/>
           <p:nvPr/>
         </p:nvSpPr>
@@ -5325,7 +5348,7 @@
       </p:sp>
       <p:sp>
         <p:nvSpPr>
-          <p:cNvPr id="26" name="Text 24"/>
+          <p:cNvPr id="27" name="Text 25"/>
           <p:cNvSpPr/>
           <p:nvPr/>
         </p:nvSpPr>
@@ -5350,7 +5373,7 @@
             <a:r>
               <a:rPr lang="en-US" sz="1200" b="1" dirty="0">
                 <a:solidFill>
-                  <a:srgbClr val="1A1A2E"/>
+                  <a:srgbClr val="2F3241"/>
                 </a:solidFill>
                 <a:latin typeface="Calibri" pitchFamily="34" charset="0"/>
                 <a:ea typeface="Calibri" pitchFamily="34" charset="-122"/>
@@ -5364,7 +5387,7 @@
       </p:sp>
       <p:sp>
         <p:nvSpPr>
-          <p:cNvPr id="27" name="Text 25"/>
+          <p:cNvPr id="28" name="Text 26"/>
           <p:cNvSpPr/>
           <p:nvPr/>
         </p:nvSpPr>
@@ -5389,7 +5412,7 @@
             <a:r>
               <a:rPr lang="en-US" sz="1200" dirty="0">
                 <a:solidFill>
-                  <a:srgbClr val="1A1A2E"/>
+                  <a:srgbClr val="2F3241"/>
                 </a:solidFill>
                 <a:latin typeface="Calibri" pitchFamily="34" charset="0"/>
                 <a:ea typeface="Calibri" pitchFamily="34" charset="-122"/>
@@ -5403,7 +5426,7 @@
       </p:sp>
       <p:sp>
         <p:nvSpPr>
-          <p:cNvPr id="28" name="Text 26"/>
+          <p:cNvPr id="29" name="Text 27"/>
           <p:cNvSpPr/>
           <p:nvPr/>
         </p:nvSpPr>
@@ -5428,7 +5451,7 @@
             <a:r>
               <a:rPr lang="en-US" sz="1200" dirty="0">
                 <a:solidFill>
-                  <a:srgbClr val="1A1A2E"/>
+                  <a:srgbClr val="2F3241"/>
                 </a:solidFill>
                 <a:latin typeface="Calibri" pitchFamily="34" charset="0"/>
                 <a:ea typeface="Calibri" pitchFamily="34" charset="-122"/>
@@ -5442,7 +5465,7 @@
       </p:sp>
       <p:sp>
         <p:nvSpPr>
-          <p:cNvPr id="29" name="Text 27"/>
+          <p:cNvPr id="30" name="Text 28"/>
           <p:cNvSpPr/>
           <p:nvPr/>
         </p:nvSpPr>
@@ -5467,7 +5490,7 @@
             <a:r>
               <a:rPr lang="en-US" sz="1200" dirty="0">
                 <a:solidFill>
-                  <a:srgbClr val="1A1A2E"/>
+                  <a:srgbClr val="2F3241"/>
                 </a:solidFill>
                 <a:latin typeface="Calibri" pitchFamily="34" charset="0"/>
                 <a:ea typeface="Calibri" pitchFamily="34" charset="-122"/>
@@ -5481,7 +5504,7 @@
       </p:sp>
       <p:sp>
         <p:nvSpPr>
-          <p:cNvPr id="30" name="Shape 28"/>
+          <p:cNvPr id="31" name="Shape 29"/>
           <p:cNvSpPr/>
           <p:nvPr/>
         </p:nvSpPr>
@@ -5504,7 +5527,7 @@
       </p:sp>
       <p:sp>
         <p:nvSpPr>
-          <p:cNvPr id="31" name="Text 29"/>
+          <p:cNvPr id="32" name="Text 30"/>
           <p:cNvSpPr/>
           <p:nvPr/>
         </p:nvSpPr>
@@ -5543,7 +5566,7 @@
       </p:sp>
       <p:sp>
         <p:nvSpPr>
-          <p:cNvPr id="32" name="Text 30"/>
+          <p:cNvPr id="33" name="Text 31"/>
           <p:cNvSpPr/>
           <p:nvPr/>
         </p:nvSpPr>
@@ -5639,7 +5662,7 @@
             <a:r>
               <a:rPr lang="en-US" sz="3200" b="1" spc="-50" kern="0" dirty="0">
                 <a:solidFill>
-                  <a:srgbClr val="1A1A2E"/>
+                  <a:srgbClr val="2F3241"/>
                 </a:solidFill>
                 <a:latin typeface="Trebuchet MS" pitchFamily="34" charset="0"/>
                 <a:ea typeface="Trebuchet MS" pitchFamily="34" charset="-122"/>
@@ -5717,7 +5740,7 @@
             <a:r>
               <a:rPr lang="en-US" sz="2200" b="1" spc="-60" kern="0" dirty="0">
                 <a:solidFill>
-                  <a:srgbClr val="1A1A2E"/>
+                  <a:srgbClr val="2F3241"/>
                 </a:solidFill>
                 <a:latin typeface="Trebuchet MS" pitchFamily="34" charset="0"/>
                 <a:ea typeface="Trebuchet MS" pitchFamily="34" charset="-122"/>
@@ -5835,7 +5858,7 @@
             <a:r>
               <a:rPr lang="en-US" sz="2600" b="1" spc="-60" kern="0" dirty="0">
                 <a:solidFill>
-                  <a:srgbClr val="1A1A2E"/>
+                  <a:srgbClr val="2F3241"/>
                 </a:solidFill>
                 <a:latin typeface="Trebuchet MS" pitchFamily="34" charset="0"/>
                 <a:ea typeface="Trebuchet MS" pitchFamily="34" charset="-122"/>
@@ -5953,7 +5976,7 @@
             <a:r>
               <a:rPr lang="en-US" sz="3000" b="1" spc="-60" kern="0" dirty="0">
                 <a:solidFill>
-                  <a:srgbClr val="1A1A2E"/>
+                  <a:srgbClr val="2F3241"/>
                 </a:solidFill>
                 <a:latin typeface="Trebuchet MS" pitchFamily="34" charset="0"/>
                 <a:ea typeface="Trebuchet MS" pitchFamily="34" charset="-122"/>
@@ -6071,7 +6094,7 @@
             <a:r>
               <a:rPr lang="en-US" sz="3600" b="1" spc="-60" kern="0" dirty="0">
                 <a:solidFill>
-                  <a:srgbClr val="1A1A2E"/>
+                  <a:srgbClr val="2F3241"/>
                 </a:solidFill>
                 <a:latin typeface="Trebuchet MS" pitchFamily="34" charset="0"/>
                 <a:ea typeface="Trebuchet MS" pitchFamily="34" charset="-122"/>
@@ -6318,7 +6341,7 @@
             <a:r>
               <a:rPr lang="en-US" sz="1400" dirty="0">
                 <a:solidFill>
-                  <a:srgbClr val="1A1A2E"/>
+                  <a:srgbClr val="2F3241"/>
                 </a:solidFill>
                 <a:latin typeface="Calibri" pitchFamily="34" charset="0"/>
                 <a:ea typeface="Calibri" pitchFamily="34" charset="-122"/>
@@ -6399,7 +6422,7 @@
             <a:r>
               <a:rPr lang="en-US" sz="1400" dirty="0">
                 <a:solidFill>
-                  <a:srgbClr val="1A1A2E"/>
+                  <a:srgbClr val="2F3241"/>
                 </a:solidFill>
                 <a:latin typeface="Calibri" pitchFamily="34" charset="0"/>
                 <a:ea typeface="Calibri" pitchFamily="34" charset="-122"/>
@@ -6480,7 +6503,7 @@
             <a:r>
               <a:rPr lang="en-US" sz="1400" dirty="0">
                 <a:solidFill>
-                  <a:srgbClr val="1A1A2E"/>
+                  <a:srgbClr val="2F3241"/>
                 </a:solidFill>
                 <a:latin typeface="Calibri" pitchFamily="34" charset="0"/>
                 <a:ea typeface="Calibri" pitchFamily="34" charset="-122"/>
@@ -6561,7 +6584,7 @@
             <a:r>
               <a:rPr lang="en-US" sz="1400" dirty="0">
                 <a:solidFill>
-                  <a:srgbClr val="1A1A2E"/>
+                  <a:srgbClr val="2F3241"/>
                 </a:solidFill>
                 <a:latin typeface="Calibri" pitchFamily="34" charset="0"/>
                 <a:ea typeface="Calibri" pitchFamily="34" charset="-122"/>
@@ -6772,7 +6795,7 @@
             <a:r>
               <a:rPr lang="en-US" sz="4400" b="1" spc="-80" kern="0" dirty="0">
                 <a:solidFill>
-                  <a:srgbClr val="1A1A2E"/>
+                  <a:srgbClr val="2F3241"/>
                 </a:solidFill>
                 <a:latin typeface="Trebuchet MS" pitchFamily="34" charset="0"/>
                 <a:ea typeface="Trebuchet MS" pitchFamily="34" charset="-122"/>
@@ -6892,7 +6915,7 @@
             <a:r>
               <a:rPr lang="en-US" sz="1500" dirty="0">
                 <a:solidFill>
-                  <a:srgbClr val="1A1A2E"/>
+                  <a:srgbClr val="2F3241"/>
                 </a:solidFill>
                 <a:latin typeface="Calibri" pitchFamily="34" charset="0"/>
                 <a:ea typeface="Calibri" pitchFamily="34" charset="-122"/>
@@ -6973,7 +6996,7 @@
             <a:r>
               <a:rPr lang="en-US" sz="1500" dirty="0">
                 <a:solidFill>
-                  <a:srgbClr val="1A1A2E"/>
+                  <a:srgbClr val="2F3241"/>
                 </a:solidFill>
                 <a:latin typeface="Calibri" pitchFamily="34" charset="0"/>
                 <a:ea typeface="Calibri" pitchFamily="34" charset="-122"/>
@@ -7054,7 +7077,7 @@
             <a:r>
               <a:rPr lang="en-US" sz="1500" dirty="0">
                 <a:solidFill>
-                  <a:srgbClr val="1A1A2E"/>
+                  <a:srgbClr val="2F3241"/>
                 </a:solidFill>
                 <a:latin typeface="Calibri" pitchFamily="34" charset="0"/>
                 <a:ea typeface="Calibri" pitchFamily="34" charset="-122"/>
@@ -7135,7 +7158,7 @@
             <a:r>
               <a:rPr lang="en-US" sz="1500" dirty="0">
                 <a:solidFill>
-                  <a:srgbClr val="1A1A2E"/>
+                  <a:srgbClr val="2F3241"/>
                 </a:solidFill>
                 <a:latin typeface="Calibri" pitchFamily="34" charset="0"/>
                 <a:ea typeface="Calibri" pitchFamily="34" charset="-122"/>
@@ -7284,7 +7307,7 @@
             <a:r>
               <a:rPr lang="en-US" sz="3400" b="1" spc="-50" kern="0" dirty="0">
                 <a:solidFill>
-                  <a:srgbClr val="1A1A2E"/>
+                  <a:srgbClr val="2F3241"/>
                 </a:solidFill>
                 <a:latin typeface="Trebuchet MS" pitchFamily="34" charset="0"/>
                 <a:ea typeface="Trebuchet MS" pitchFamily="34" charset="-122"/>
@@ -7404,7 +7427,7 @@
             <a:r>
               <a:rPr lang="en-US" sz="1300" dirty="0">
                 <a:solidFill>
-                  <a:srgbClr val="1A1A2E"/>
+                  <a:srgbClr val="2F3241"/>
                 </a:solidFill>
                 <a:latin typeface="Calibri" pitchFamily="34" charset="0"/>
                 <a:ea typeface="Calibri" pitchFamily="34" charset="-122"/>
@@ -7547,7 +7570,7 @@
             <a:r>
               <a:rPr lang="en-US" sz="1300" dirty="0">
                 <a:solidFill>
-                  <a:srgbClr val="1A1A2E"/>
+                  <a:srgbClr val="2F3241"/>
                 </a:solidFill>
                 <a:latin typeface="Calibri" pitchFamily="34" charset="0"/>
                 <a:ea typeface="Calibri" pitchFamily="34" charset="-122"/>
@@ -7690,7 +7713,7 @@
             <a:r>
               <a:rPr lang="en-US" sz="1300" dirty="0">
                 <a:solidFill>
-                  <a:srgbClr val="1A1A2E"/>
+                  <a:srgbClr val="2F3241"/>
                 </a:solidFill>
                 <a:latin typeface="Calibri" pitchFamily="34" charset="0"/>
                 <a:ea typeface="Calibri" pitchFamily="34" charset="-122"/>
@@ -7862,7 +7885,7 @@
             <a:r>
               <a:rPr lang="en-US" sz="3200" b="1" spc="-50" kern="0" dirty="0">
                 <a:solidFill>
-                  <a:srgbClr val="1A1A2E"/>
+                  <a:srgbClr val="2F3241"/>
                 </a:solidFill>
                 <a:latin typeface="Trebuchet MS" pitchFamily="34" charset="0"/>
                 <a:ea typeface="Trebuchet MS" pitchFamily="34" charset="-122"/>
@@ -7940,7 +7963,7 @@
             <a:r>
               <a:rPr lang="en-US" sz="1700" b="1" spc="-30" kern="0" dirty="0">
                 <a:solidFill>
-                  <a:srgbClr val="1A1A2E"/>
+                  <a:srgbClr val="2F3241"/>
                 </a:solidFill>
                 <a:latin typeface="Trebuchet MS" pitchFamily="34" charset="0"/>
                 <a:ea typeface="Trebuchet MS" pitchFamily="34" charset="-122"/>
@@ -7982,7 +8005,7 @@
             <a:r>
               <a:rPr lang="en-US" sz="1200" dirty="0">
                 <a:solidFill>
-                  <a:srgbClr val="1A1A2E"/>
+                  <a:srgbClr val="2F3241"/>
                 </a:solidFill>
                 <a:latin typeface="Calibri" pitchFamily="34" charset="0"/>
                 <a:ea typeface="Calibri" pitchFamily="34" charset="-122"/>
@@ -8021,7 +8044,7 @@
             <a:r>
               <a:rPr lang="en-US" sz="1100" i="1" dirty="0">
                 <a:solidFill>
-                  <a:srgbClr val="C22299"/>
+                  <a:srgbClr val="C43C96"/>
                 </a:solidFill>
                 <a:latin typeface="Calibri" pitchFamily="34" charset="0"/>
                 <a:ea typeface="Calibri" pitchFamily="34" charset="-122"/>
@@ -8060,7 +8083,7 @@
             <a:r>
               <a:rPr lang="en-US" sz="1700" b="1" spc="-30" kern="0" dirty="0">
                 <a:solidFill>
-                  <a:srgbClr val="1A1A2E"/>
+                  <a:srgbClr val="2F3241"/>
                 </a:solidFill>
                 <a:latin typeface="Trebuchet MS" pitchFamily="34" charset="0"/>
                 <a:ea typeface="Trebuchet MS" pitchFamily="34" charset="-122"/>
@@ -8102,7 +8125,7 @@
             <a:r>
               <a:rPr lang="en-US" sz="1200" dirty="0">
                 <a:solidFill>
-                  <a:srgbClr val="1A1A2E"/>
+                  <a:srgbClr val="2F3241"/>
                 </a:solidFill>
                 <a:latin typeface="Calibri" pitchFamily="34" charset="0"/>
                 <a:ea typeface="Calibri" pitchFamily="34" charset="-122"/>
@@ -8141,7 +8164,7 @@
             <a:r>
               <a:rPr lang="en-US" sz="1100" i="1" dirty="0">
                 <a:solidFill>
-                  <a:srgbClr val="C22299"/>
+                  <a:srgbClr val="C43C96"/>
                 </a:solidFill>
                 <a:latin typeface="Calibri" pitchFamily="34" charset="0"/>
                 <a:ea typeface="Calibri" pitchFamily="34" charset="-122"/>
@@ -8180,7 +8203,7 @@
             <a:r>
               <a:rPr lang="en-US" sz="1700" b="1" spc="-30" kern="0" dirty="0">
                 <a:solidFill>
-                  <a:srgbClr val="1A1A2E"/>
+                  <a:srgbClr val="2F3241"/>
                 </a:solidFill>
                 <a:latin typeface="Trebuchet MS" pitchFamily="34" charset="0"/>
                 <a:ea typeface="Trebuchet MS" pitchFamily="34" charset="-122"/>
@@ -8222,7 +8245,7 @@
             <a:r>
               <a:rPr lang="en-US" sz="1200" dirty="0">
                 <a:solidFill>
-                  <a:srgbClr val="1A1A2E"/>
+                  <a:srgbClr val="2F3241"/>
                 </a:solidFill>
                 <a:latin typeface="Calibri" pitchFamily="34" charset="0"/>
                 <a:ea typeface="Calibri" pitchFamily="34" charset="-122"/>
@@ -8261,7 +8284,7 @@
             <a:r>
               <a:rPr lang="en-US" sz="1100" i="1" dirty="0">
                 <a:solidFill>
-                  <a:srgbClr val="C22299"/>
+                  <a:srgbClr val="C43C96"/>
                 </a:solidFill>
                 <a:latin typeface="Calibri" pitchFamily="34" charset="0"/>
                 <a:ea typeface="Calibri" pitchFamily="34" charset="-122"/>
@@ -8300,7 +8323,7 @@
             <a:r>
               <a:rPr lang="en-US" sz="1700" b="1" spc="-30" kern="0" dirty="0">
                 <a:solidFill>
-                  <a:srgbClr val="1A1A2E"/>
+                  <a:srgbClr val="2F3241"/>
                 </a:solidFill>
                 <a:latin typeface="Trebuchet MS" pitchFamily="34" charset="0"/>
                 <a:ea typeface="Trebuchet MS" pitchFamily="34" charset="-122"/>
@@ -8342,7 +8365,7 @@
             <a:r>
               <a:rPr lang="en-US" sz="1200" dirty="0">
                 <a:solidFill>
-                  <a:srgbClr val="1A1A2E"/>
+                  <a:srgbClr val="2F3241"/>
                 </a:solidFill>
                 <a:latin typeface="Calibri" pitchFamily="34" charset="0"/>
                 <a:ea typeface="Calibri" pitchFamily="34" charset="-122"/>
@@ -8381,7 +8404,7 @@
             <a:r>
               <a:rPr lang="en-US" sz="1100" i="1" dirty="0">
                 <a:solidFill>
-                  <a:srgbClr val="C22299"/>
+                  <a:srgbClr val="C43C96"/>
                 </a:solidFill>
                 <a:latin typeface="Calibri" pitchFamily="34" charset="0"/>
                 <a:ea typeface="Calibri" pitchFamily="34" charset="-122"/>
@@ -8569,7 +8592,7 @@
             <a:r>
               <a:rPr lang="en-US" sz="2800" b="1" spc="-50" kern="0" dirty="0">
                 <a:solidFill>
-                  <a:srgbClr val="1A1A2E"/>
+                  <a:srgbClr val="2F3241"/>
                 </a:solidFill>
                 <a:latin typeface="Trebuchet MS" pitchFamily="34" charset="0"/>
                 <a:ea typeface="Trebuchet MS" pitchFamily="34" charset="-122"/>
@@ -8712,7 +8735,7 @@
             <a:r>
               <a:rPr lang="en-US" sz="1300" b="1" dirty="0">
                 <a:solidFill>
-                  <a:srgbClr val="1A1A2E"/>
+                  <a:srgbClr val="2F3241"/>
                 </a:solidFill>
                 <a:latin typeface="Calibri" pitchFamily="34" charset="0"/>
                 <a:ea typeface="Calibri" pitchFamily="34" charset="-122"/>
@@ -8754,7 +8777,7 @@
             <a:r>
               <a:rPr lang="en-US" sz="1300" dirty="0">
                 <a:solidFill>
-                  <a:srgbClr val="1A1A2E"/>
+                  <a:srgbClr val="2F3241"/>
                 </a:solidFill>
                 <a:latin typeface="Calibri" pitchFamily="34" charset="0"/>
                 <a:ea typeface="Calibri" pitchFamily="34" charset="-122"/>
@@ -8819,7 +8842,7 @@
             <a:r>
               <a:rPr lang="en-US" sz="1300" b="1" dirty="0">
                 <a:solidFill>
-                  <a:srgbClr val="1A1A2E"/>
+                  <a:srgbClr val="2F3241"/>
                 </a:solidFill>
                 <a:latin typeface="Calibri" pitchFamily="34" charset="0"/>
                 <a:ea typeface="Calibri" pitchFamily="34" charset="-122"/>
@@ -8861,7 +8884,7 @@
             <a:r>
               <a:rPr lang="en-US" sz="1300" dirty="0">
                 <a:solidFill>
-                  <a:srgbClr val="1A1A2E"/>
+                  <a:srgbClr val="2F3241"/>
                 </a:solidFill>
                 <a:latin typeface="Calibri" pitchFamily="34" charset="0"/>
                 <a:ea typeface="Calibri" pitchFamily="34" charset="-122"/>
@@ -8926,7 +8949,7 @@
             <a:r>
               <a:rPr lang="en-US" sz="1300" b="1" dirty="0">
                 <a:solidFill>
-                  <a:srgbClr val="1A1A2E"/>
+                  <a:srgbClr val="2F3241"/>
                 </a:solidFill>
                 <a:latin typeface="Calibri" pitchFamily="34" charset="0"/>
                 <a:ea typeface="Calibri" pitchFamily="34" charset="-122"/>
@@ -8968,7 +8991,7 @@
             <a:r>
               <a:rPr lang="en-US" sz="1300" dirty="0">
                 <a:solidFill>
-                  <a:srgbClr val="1A1A2E"/>
+                  <a:srgbClr val="2F3241"/>
                 </a:solidFill>
                 <a:latin typeface="Calibri" pitchFamily="34" charset="0"/>
                 <a:ea typeface="Calibri" pitchFamily="34" charset="-122"/>
@@ -9033,7 +9056,7 @@
             <a:r>
               <a:rPr lang="en-US" sz="1300" b="1" dirty="0">
                 <a:solidFill>
-                  <a:srgbClr val="1A1A2E"/>
+                  <a:srgbClr val="2F3241"/>
                 </a:solidFill>
                 <a:latin typeface="Calibri" pitchFamily="34" charset="0"/>
                 <a:ea typeface="Calibri" pitchFamily="34" charset="-122"/>
@@ -9075,7 +9098,7 @@
             <a:r>
               <a:rPr lang="en-US" sz="1300" dirty="0">
                 <a:solidFill>
-                  <a:srgbClr val="1A1A2E"/>
+                  <a:srgbClr val="2F3241"/>
                 </a:solidFill>
                 <a:latin typeface="Calibri" pitchFamily="34" charset="0"/>
                 <a:ea typeface="Calibri" pitchFamily="34" charset="-122"/>
@@ -9140,7 +9163,7 @@
             <a:r>
               <a:rPr lang="en-US" sz="1300" b="1" dirty="0">
                 <a:solidFill>
-                  <a:srgbClr val="1A1A2E"/>
+                  <a:srgbClr val="2F3241"/>
                 </a:solidFill>
                 <a:latin typeface="Calibri" pitchFamily="34" charset="0"/>
                 <a:ea typeface="Calibri" pitchFamily="34" charset="-122"/>
@@ -9182,7 +9205,7 @@
             <a:r>
               <a:rPr lang="en-US" sz="1300" dirty="0">
                 <a:solidFill>
-                  <a:srgbClr val="1A1A2E"/>
+                  <a:srgbClr val="2F3241"/>
                 </a:solidFill>
                 <a:latin typeface="Calibri" pitchFamily="34" charset="0"/>
                 <a:ea typeface="Calibri" pitchFamily="34" charset="-122"/>
@@ -9247,7 +9270,7 @@
             <a:r>
               <a:rPr lang="en-US" sz="1300" b="1" dirty="0">
                 <a:solidFill>
-                  <a:srgbClr val="1A1A2E"/>
+                  <a:srgbClr val="2F3241"/>
                 </a:solidFill>
                 <a:latin typeface="Calibri" pitchFamily="34" charset="0"/>
                 <a:ea typeface="Calibri" pitchFamily="34" charset="-122"/>
@@ -9289,7 +9312,7 @@
             <a:r>
               <a:rPr lang="en-US" sz="1300" dirty="0">
                 <a:solidFill>
-                  <a:srgbClr val="1A1A2E"/>
+                  <a:srgbClr val="2F3241"/>
                 </a:solidFill>
                 <a:latin typeface="Calibri" pitchFamily="34" charset="0"/>
                 <a:ea typeface="Calibri" pitchFamily="34" charset="-122"/>
@@ -9461,7 +9484,7 @@
             <a:r>
               <a:rPr lang="en-US" sz="2400" b="1" spc="-50" kern="0" dirty="0">
                 <a:solidFill>
-                  <a:srgbClr val="1A1A2E"/>
+                  <a:srgbClr val="2F3241"/>
                 </a:solidFill>
                 <a:latin typeface="Trebuchet MS" pitchFamily="34" charset="0"/>
                 <a:ea typeface="Trebuchet MS" pitchFamily="34" charset="-122"/>
@@ -9718,7 +9741,7 @@
             <a:r>
               <a:rPr lang="en-US" sz="1100" dirty="0">
                 <a:solidFill>
-                  <a:srgbClr val="1A1A2E"/>
+                  <a:srgbClr val="2F3241"/>
                 </a:solidFill>
                 <a:latin typeface="Calibri" pitchFamily="34" charset="0"/>
                 <a:ea typeface="Calibri" pitchFamily="34" charset="-122"/>
@@ -9858,7 +9881,7 @@
             <a:r>
               <a:rPr lang="en-US" sz="1100" dirty="0">
                 <a:solidFill>
-                  <a:srgbClr val="1A1A2E"/>
+                  <a:srgbClr val="2F3241"/>
                 </a:solidFill>
                 <a:latin typeface="Calibri" pitchFamily="34" charset="0"/>
                 <a:ea typeface="Calibri" pitchFamily="34" charset="-122"/>
@@ -9998,7 +10021,7 @@
             <a:r>
               <a:rPr lang="en-US" sz="1100" dirty="0">
                 <a:solidFill>
-                  <a:srgbClr val="1A1A2E"/>
+                  <a:srgbClr val="2F3241"/>
                 </a:solidFill>
                 <a:latin typeface="Calibri" pitchFamily="34" charset="0"/>
                 <a:ea typeface="Calibri" pitchFamily="34" charset="-122"/>
@@ -10138,7 +10161,7 @@
             <a:r>
               <a:rPr lang="en-US" sz="1100" dirty="0">
                 <a:solidFill>
-                  <a:srgbClr val="1A1A2E"/>
+                  <a:srgbClr val="2F3241"/>
                 </a:solidFill>
                 <a:latin typeface="Calibri" pitchFamily="34" charset="0"/>
                 <a:ea typeface="Calibri" pitchFamily="34" charset="-122"/>
@@ -10278,7 +10301,7 @@
             <a:r>
               <a:rPr lang="en-US" sz="1100" dirty="0">
                 <a:solidFill>
-                  <a:srgbClr val="1A1A2E"/>
+                  <a:srgbClr val="2F3241"/>
                 </a:solidFill>
                 <a:latin typeface="Calibri" pitchFamily="34" charset="0"/>
                 <a:ea typeface="Calibri" pitchFamily="34" charset="-122"/>
@@ -10418,7 +10441,7 @@
             <a:r>
               <a:rPr lang="en-US" sz="1100" dirty="0">
                 <a:solidFill>
-                  <a:srgbClr val="1A1A2E"/>
+                  <a:srgbClr val="2F3241"/>
                 </a:solidFill>
                 <a:latin typeface="Calibri" pitchFamily="34" charset="0"/>
                 <a:ea typeface="Calibri" pitchFamily="34" charset="-122"/>
@@ -10558,7 +10581,7 @@
             <a:r>
               <a:rPr lang="en-US" sz="1100" dirty="0">
                 <a:solidFill>
-                  <a:srgbClr val="1A1A2E"/>
+                  <a:srgbClr val="2F3241"/>
                 </a:solidFill>
                 <a:latin typeface="Calibri" pitchFamily="34" charset="0"/>
                 <a:ea typeface="Calibri" pitchFamily="34" charset="-122"/>
@@ -10698,7 +10721,7 @@
             <a:r>
               <a:rPr lang="en-US" sz="1100" dirty="0">
                 <a:solidFill>
-                  <a:srgbClr val="1A1A2E"/>
+                  <a:srgbClr val="2F3241"/>
                 </a:solidFill>
                 <a:latin typeface="Calibri" pitchFamily="34" charset="0"/>
                 <a:ea typeface="Calibri" pitchFamily="34" charset="-122"/>
@@ -10838,7 +10861,7 @@
             <a:r>
               <a:rPr lang="en-US" sz="1100" dirty="0">
                 <a:solidFill>
-                  <a:srgbClr val="1A1A2E"/>
+                  <a:srgbClr val="2F3241"/>
                 </a:solidFill>
                 <a:latin typeface="Calibri" pitchFamily="34" charset="0"/>
                 <a:ea typeface="Calibri" pitchFamily="34" charset="-122"/>
@@ -10978,7 +11001,7 @@
             <a:r>
               <a:rPr lang="en-US" sz="1100" dirty="0">
                 <a:solidFill>
-                  <a:srgbClr val="1A1A2E"/>
+                  <a:srgbClr val="2F3241"/>
                 </a:solidFill>
                 <a:latin typeface="Calibri" pitchFamily="34" charset="0"/>
                 <a:ea typeface="Calibri" pitchFamily="34" charset="-122"/>
@@ -11118,7 +11141,7 @@
             <a:r>
               <a:rPr lang="en-US" sz="1100" dirty="0">
                 <a:solidFill>
-                  <a:srgbClr val="1A1A2E"/>
+                  <a:srgbClr val="2F3241"/>
                 </a:solidFill>
                 <a:latin typeface="Calibri" pitchFamily="34" charset="0"/>
                 <a:ea typeface="Calibri" pitchFamily="34" charset="-122"/>
@@ -11258,7 +11281,7 @@
             <a:r>
               <a:rPr lang="en-US" sz="1100" dirty="0">
                 <a:solidFill>
-                  <a:srgbClr val="1A1A2E"/>
+                  <a:srgbClr val="2F3241"/>
                 </a:solidFill>
                 <a:latin typeface="Calibri" pitchFamily="34" charset="0"/>
                 <a:ea typeface="Calibri" pitchFamily="34" charset="-122"/>
@@ -11578,7 +11601,7 @@
             <a:r>
               <a:rPr lang="en-US" sz="2600" b="1" spc="-50" kern="0" dirty="0">
                 <a:solidFill>
-                  <a:srgbClr val="1A1A2E"/>
+                  <a:srgbClr val="2F3241"/>
                 </a:solidFill>
                 <a:latin typeface="Trebuchet MS" pitchFamily="34" charset="0"/>
                 <a:ea typeface="Trebuchet MS" pitchFamily="34" charset="-122"/>
@@ -11598,7 +11621,7 @@
             <a:r>
               <a:rPr lang="en-US" sz="2600" b="1" spc="-50" kern="0" dirty="0">
                 <a:solidFill>
-                  <a:srgbClr val="1A1A2E"/>
+                  <a:srgbClr val="2F3241"/>
                 </a:solidFill>
                 <a:latin typeface="Trebuchet MS" pitchFamily="34" charset="0"/>
                 <a:ea typeface="Trebuchet MS" pitchFamily="34" charset="-122"/>
@@ -11643,7 +11666,7 @@
             <a:r>
               <a:rPr lang="en-US" sz="1400" b="1" dirty="0">
                 <a:solidFill>
-                  <a:srgbClr val="1A1A2E"/>
+                  <a:srgbClr val="2F3241"/>
                 </a:solidFill>
                 <a:latin typeface="Calibri" pitchFamily="34" charset="0"/>
                 <a:ea typeface="Calibri" pitchFamily="34" charset="-122"/>
@@ -11663,7 +11686,7 @@
             <a:r>
               <a:rPr lang="en-US" sz="1400" dirty="0">
                 <a:solidFill>
-                  <a:srgbClr val="1A1A2E"/>
+                  <a:srgbClr val="2F3241"/>
                 </a:solidFill>
                 <a:latin typeface="Calibri" pitchFamily="34" charset="0"/>
                 <a:ea typeface="Calibri" pitchFamily="34" charset="-122"/>
@@ -11683,7 +11706,7 @@
             <a:r>
               <a:rPr lang="en-US" sz="1400" b="1" dirty="0">
                 <a:solidFill>
-                  <a:srgbClr val="1A1A2E"/>
+                  <a:srgbClr val="2F3241"/>
                 </a:solidFill>
                 <a:latin typeface="Calibri" pitchFamily="34" charset="0"/>
                 <a:ea typeface="Calibri" pitchFamily="34" charset="-122"/>
@@ -11703,7 +11726,7 @@
             <a:r>
               <a:rPr lang="en-US" sz="1400" dirty="0">
                 <a:solidFill>
-                  <a:srgbClr val="1A1A2E"/>
+                  <a:srgbClr val="2F3241"/>
                 </a:solidFill>
                 <a:latin typeface="Calibri" pitchFamily="34" charset="0"/>
                 <a:ea typeface="Calibri" pitchFamily="34" charset="-122"/>
@@ -11723,7 +11746,7 @@
             <a:r>
               <a:rPr lang="en-US" sz="1400" b="1" dirty="0">
                 <a:solidFill>
-                  <a:srgbClr val="1A1A2E"/>
+                  <a:srgbClr val="2F3241"/>
                 </a:solidFill>
                 <a:latin typeface="Calibri" pitchFamily="34" charset="0"/>
                 <a:ea typeface="Calibri" pitchFamily="34" charset="-122"/>
@@ -11743,7 +11766,7 @@
             <a:r>
               <a:rPr lang="en-US" sz="1400" dirty="0">
                 <a:solidFill>
-                  <a:srgbClr val="1A1A2E"/>
+                  <a:srgbClr val="2F3241"/>
                 </a:solidFill>
                 <a:latin typeface="Calibri" pitchFamily="34" charset="0"/>
                 <a:ea typeface="Calibri" pitchFamily="34" charset="-122"/>
@@ -12032,7 +12055,7 @@
             <a:r>
               <a:rPr lang="en-US" sz="17000" b="1" spc="-800" kern="0" dirty="0">
                 <a:solidFill>
-                  <a:srgbClr val="1A1A2E"/>
+                  <a:srgbClr val="2F3241"/>
                 </a:solidFill>
                 <a:latin typeface="Trebuchet MS" pitchFamily="34" charset="0"/>
                 <a:ea typeface="Trebuchet MS" pitchFamily="34" charset="-122"/>
@@ -12046,7 +12069,30 @@
       </p:sp>
       <p:sp>
         <p:nvSpPr>
-          <p:cNvPr id="4" name="Text 2"/>
+          <p:cNvPr id="4" name="Shape 2"/>
+          <p:cNvSpPr/>
+          <p:nvPr/>
+        </p:nvSpPr>
+        <p:spPr>
+          <a:xfrm>
+            <a:off x="822960" y="3200400"/>
+            <a:ext cx="1280160" cy="0"/>
+          </a:xfrm>
+          <a:prstGeom prst="line">
+            <a:avLst/>
+          </a:prstGeom>
+          <a:noFill/>
+          <a:ln w="28575">
+            <a:solidFill>
+              <a:srgbClr val="FFB01A"/>
+            </a:solidFill>
+            <a:prstDash val="solid"/>
+          </a:ln>
+        </p:spPr>
+      </p:sp>
+      <p:sp>
+        <p:nvSpPr>
+          <p:cNvPr id="5" name="Text 3"/>
           <p:cNvSpPr/>
           <p:nvPr/>
         </p:nvSpPr>
@@ -12085,7 +12131,7 @@
       </p:sp>
       <p:sp>
         <p:nvSpPr>
-          <p:cNvPr id="5" name="Shape 3"/>
+          <p:cNvPr id="6" name="Shape 4"/>
           <p:cNvSpPr/>
           <p:nvPr/>
         </p:nvSpPr>
@@ -12108,7 +12154,7 @@
       </p:sp>
       <p:sp>
         <p:nvSpPr>
-          <p:cNvPr id="6" name="Text 4"/>
+          <p:cNvPr id="7" name="Text 5"/>
           <p:cNvSpPr/>
           <p:nvPr/>
         </p:nvSpPr>
@@ -12147,7 +12193,7 @@
       </p:sp>
       <p:sp>
         <p:nvSpPr>
-          <p:cNvPr id="7" name="Text 5"/>
+          <p:cNvPr id="8" name="Text 6"/>
           <p:cNvSpPr/>
           <p:nvPr/>
         </p:nvSpPr>
@@ -12186,7 +12232,7 @@
       </p:sp>
       <p:sp>
         <p:nvSpPr>
-          <p:cNvPr id="8" name="Text 6"/>
+          <p:cNvPr id="9" name="Text 7"/>
           <p:cNvSpPr/>
           <p:nvPr/>
         </p:nvSpPr>
@@ -12214,7 +12260,7 @@
             <a:r>
               <a:rPr lang="en-US" sz="1200" dirty="0">
                 <a:solidFill>
-                  <a:srgbClr val="1A1A2E"/>
+                  <a:srgbClr val="2F3241"/>
                 </a:solidFill>
                 <a:latin typeface="Calibri" pitchFamily="34" charset="0"/>
                 <a:ea typeface="Calibri" pitchFamily="34" charset="-122"/>
@@ -12228,7 +12274,7 @@
       </p:sp>
       <p:sp>
         <p:nvSpPr>
-          <p:cNvPr id="9" name="Shape 7"/>
+          <p:cNvPr id="10" name="Shape 8"/>
           <p:cNvSpPr/>
           <p:nvPr/>
         </p:nvSpPr>
@@ -12251,7 +12297,7 @@
       </p:sp>
       <p:sp>
         <p:nvSpPr>
-          <p:cNvPr id="10" name="Text 8"/>
+          <p:cNvPr id="11" name="Text 9"/>
           <p:cNvSpPr/>
           <p:nvPr/>
         </p:nvSpPr>
@@ -12290,7 +12336,7 @@
       </p:sp>
       <p:sp>
         <p:nvSpPr>
-          <p:cNvPr id="11" name="Text 9"/>
+          <p:cNvPr id="12" name="Text 10"/>
           <p:cNvSpPr/>
           <p:nvPr/>
         </p:nvSpPr>
@@ -12329,7 +12375,7 @@
       </p:sp>
       <p:sp>
         <p:nvSpPr>
-          <p:cNvPr id="12" name="Text 10"/>
+          <p:cNvPr id="13" name="Text 11"/>
           <p:cNvSpPr/>
           <p:nvPr/>
         </p:nvSpPr>
@@ -12357,7 +12403,7 @@
             <a:r>
               <a:rPr lang="en-US" sz="1200" dirty="0">
                 <a:solidFill>
-                  <a:srgbClr val="1A1A2E"/>
+                  <a:srgbClr val="2F3241"/>
                 </a:solidFill>
                 <a:latin typeface="Calibri" pitchFamily="34" charset="0"/>
                 <a:ea typeface="Calibri" pitchFamily="34" charset="-122"/>
@@ -12371,7 +12417,7 @@
       </p:sp>
       <p:sp>
         <p:nvSpPr>
-          <p:cNvPr id="13" name="Shape 11"/>
+          <p:cNvPr id="14" name="Shape 12"/>
           <p:cNvSpPr/>
           <p:nvPr/>
         </p:nvSpPr>
@@ -12394,7 +12440,7 @@
       </p:sp>
       <p:sp>
         <p:nvSpPr>
-          <p:cNvPr id="14" name="Text 12"/>
+          <p:cNvPr id="15" name="Text 13"/>
           <p:cNvSpPr/>
           <p:nvPr/>
         </p:nvSpPr>
@@ -12433,7 +12479,7 @@
       </p:sp>
       <p:sp>
         <p:nvSpPr>
-          <p:cNvPr id="15" name="Text 13"/>
+          <p:cNvPr id="16" name="Text 14"/>
           <p:cNvSpPr/>
           <p:nvPr/>
         </p:nvSpPr>
@@ -12472,7 +12518,7 @@
       </p:sp>
       <p:sp>
         <p:nvSpPr>
-          <p:cNvPr id="16" name="Text 14"/>
+          <p:cNvPr id="17" name="Text 15"/>
           <p:cNvSpPr/>
           <p:nvPr/>
         </p:nvSpPr>
@@ -12500,7 +12546,7 @@
             <a:r>
               <a:rPr lang="en-US" sz="1200" dirty="0">
                 <a:solidFill>
-                  <a:srgbClr val="1A1A2E"/>
+                  <a:srgbClr val="2F3241"/>
                 </a:solidFill>
                 <a:latin typeface="Calibri" pitchFamily="34" charset="0"/>
                 <a:ea typeface="Calibri" pitchFamily="34" charset="-122"/>
@@ -12514,7 +12560,7 @@
       </p:sp>
       <p:sp>
         <p:nvSpPr>
-          <p:cNvPr id="17" name="Shape 15"/>
+          <p:cNvPr id="18" name="Shape 16"/>
           <p:cNvSpPr/>
           <p:nvPr/>
         </p:nvSpPr>
@@ -12537,7 +12583,7 @@
       </p:sp>
       <p:sp>
         <p:nvSpPr>
-          <p:cNvPr id="18" name="Text 16"/>
+          <p:cNvPr id="19" name="Text 17"/>
           <p:cNvSpPr/>
           <p:nvPr/>
         </p:nvSpPr>
@@ -12576,7 +12622,7 @@
       </p:sp>
       <p:sp>
         <p:nvSpPr>
-          <p:cNvPr id="19" name="Text 17"/>
+          <p:cNvPr id="20" name="Text 18"/>
           <p:cNvSpPr/>
           <p:nvPr/>
         </p:nvSpPr>
@@ -12672,7 +12718,7 @@
             <a:r>
               <a:rPr lang="en-US" sz="2600" b="1" spc="-50" kern="0" dirty="0">
                 <a:solidFill>
-                  <a:srgbClr val="1A1A2E"/>
+                  <a:srgbClr val="2F3241"/>
                 </a:solidFill>
                 <a:latin typeface="Trebuchet MS" pitchFamily="34" charset="0"/>
                 <a:ea typeface="Trebuchet MS" pitchFamily="34" charset="-122"/>
@@ -12890,7 +12936,7 @@
             <a:r>
               <a:rPr lang="en-US" sz="1200" b="1" dirty="0">
                 <a:solidFill>
-                  <a:srgbClr val="1A1A2E"/>
+                  <a:srgbClr val="2F3241"/>
                 </a:solidFill>
                 <a:latin typeface="Calibri" pitchFamily="34" charset="0"/>
                 <a:ea typeface="Calibri" pitchFamily="34" charset="-122"/>
@@ -12929,7 +12975,7 @@
             <a:r>
               <a:rPr lang="en-US" sz="1200" dirty="0">
                 <a:solidFill>
-                  <a:srgbClr val="1A1A2E"/>
+                  <a:srgbClr val="2F3241"/>
                 </a:solidFill>
                 <a:latin typeface="Calibri" pitchFamily="34" charset="0"/>
                 <a:ea typeface="Calibri" pitchFamily="34" charset="-122"/>
@@ -12968,7 +13014,7 @@
             <a:r>
               <a:rPr lang="en-US" sz="1200" dirty="0">
                 <a:solidFill>
-                  <a:srgbClr val="1A1A2E"/>
+                  <a:srgbClr val="2F3241"/>
                 </a:solidFill>
                 <a:latin typeface="Calibri" pitchFamily="34" charset="0"/>
                 <a:ea typeface="Calibri" pitchFamily="34" charset="-122"/>
@@ -13030,7 +13076,7 @@
             <a:r>
               <a:rPr lang="en-US" sz="1200" b="1" dirty="0">
                 <a:solidFill>
-                  <a:srgbClr val="1A1A2E"/>
+                  <a:srgbClr val="2F3241"/>
                 </a:solidFill>
                 <a:latin typeface="Calibri" pitchFamily="34" charset="0"/>
                 <a:ea typeface="Calibri" pitchFamily="34" charset="-122"/>
@@ -13069,7 +13115,7 @@
             <a:r>
               <a:rPr lang="en-US" sz="1200" dirty="0">
                 <a:solidFill>
-                  <a:srgbClr val="1A1A2E"/>
+                  <a:srgbClr val="2F3241"/>
                 </a:solidFill>
                 <a:latin typeface="Calibri" pitchFamily="34" charset="0"/>
                 <a:ea typeface="Calibri" pitchFamily="34" charset="-122"/>
@@ -13108,7 +13154,7 @@
             <a:r>
               <a:rPr lang="en-US" sz="1200" dirty="0">
                 <a:solidFill>
-                  <a:srgbClr val="1A1A2E"/>
+                  <a:srgbClr val="2F3241"/>
                 </a:solidFill>
                 <a:latin typeface="Calibri" pitchFamily="34" charset="0"/>
                 <a:ea typeface="Calibri" pitchFamily="34" charset="-122"/>
@@ -13170,7 +13216,7 @@
             <a:r>
               <a:rPr lang="en-US" sz="1200" b="1" dirty="0">
                 <a:solidFill>
-                  <a:srgbClr val="1A1A2E"/>
+                  <a:srgbClr val="2F3241"/>
                 </a:solidFill>
                 <a:latin typeface="Calibri" pitchFamily="34" charset="0"/>
                 <a:ea typeface="Calibri" pitchFamily="34" charset="-122"/>
@@ -13209,7 +13255,7 @@
             <a:r>
               <a:rPr lang="en-US" sz="1200" dirty="0">
                 <a:solidFill>
-                  <a:srgbClr val="1A1A2E"/>
+                  <a:srgbClr val="2F3241"/>
                 </a:solidFill>
                 <a:latin typeface="Calibri" pitchFamily="34" charset="0"/>
                 <a:ea typeface="Calibri" pitchFamily="34" charset="-122"/>
@@ -13248,7 +13294,7 @@
             <a:r>
               <a:rPr lang="en-US" sz="1200" dirty="0">
                 <a:solidFill>
-                  <a:srgbClr val="1A1A2E"/>
+                  <a:srgbClr val="2F3241"/>
                 </a:solidFill>
                 <a:latin typeface="Calibri" pitchFamily="34" charset="0"/>
                 <a:ea typeface="Calibri" pitchFamily="34" charset="-122"/>
@@ -13310,7 +13356,7 @@
             <a:r>
               <a:rPr lang="en-US" sz="1200" b="1" dirty="0">
                 <a:solidFill>
-                  <a:srgbClr val="1A1A2E"/>
+                  <a:srgbClr val="2F3241"/>
                 </a:solidFill>
                 <a:latin typeface="Calibri" pitchFamily="34" charset="0"/>
                 <a:ea typeface="Calibri" pitchFamily="34" charset="-122"/>
@@ -13349,7 +13395,7 @@
             <a:r>
               <a:rPr lang="en-US" sz="1200" dirty="0">
                 <a:solidFill>
-                  <a:srgbClr val="1A1A2E"/>
+                  <a:srgbClr val="2F3241"/>
                 </a:solidFill>
                 <a:latin typeface="Calibri" pitchFamily="34" charset="0"/>
                 <a:ea typeface="Calibri" pitchFamily="34" charset="-122"/>
@@ -13388,7 +13434,7 @@
             <a:r>
               <a:rPr lang="en-US" sz="1200" dirty="0">
                 <a:solidFill>
-                  <a:srgbClr val="1A1A2E"/>
+                  <a:srgbClr val="2F3241"/>
                 </a:solidFill>
                 <a:latin typeface="Calibri" pitchFamily="34" charset="0"/>
                 <a:ea typeface="Calibri" pitchFamily="34" charset="-122"/>
@@ -13450,7 +13496,7 @@
             <a:r>
               <a:rPr lang="en-US" sz="1200" b="1" dirty="0">
                 <a:solidFill>
-                  <a:srgbClr val="1A1A2E"/>
+                  <a:srgbClr val="2F3241"/>
                 </a:solidFill>
                 <a:latin typeface="Calibri" pitchFamily="34" charset="0"/>
                 <a:ea typeface="Calibri" pitchFamily="34" charset="-122"/>
@@ -13489,7 +13535,7 @@
             <a:r>
               <a:rPr lang="en-US" sz="1200" dirty="0">
                 <a:solidFill>
-                  <a:srgbClr val="1A1A2E"/>
+                  <a:srgbClr val="2F3241"/>
                 </a:solidFill>
                 <a:latin typeface="Calibri" pitchFamily="34" charset="0"/>
                 <a:ea typeface="Calibri" pitchFamily="34" charset="-122"/>
@@ -13528,7 +13574,7 @@
             <a:r>
               <a:rPr lang="en-US" sz="1200" dirty="0">
                 <a:solidFill>
-                  <a:srgbClr val="1A1A2E"/>
+                  <a:srgbClr val="2F3241"/>
                 </a:solidFill>
                 <a:latin typeface="Calibri" pitchFamily="34" charset="0"/>
                 <a:ea typeface="Calibri" pitchFamily="34" charset="-122"/>
@@ -13590,7 +13636,7 @@
             <a:r>
               <a:rPr lang="en-US" sz="1200" b="1" dirty="0">
                 <a:solidFill>
-                  <a:srgbClr val="1A1A2E"/>
+                  <a:srgbClr val="2F3241"/>
                 </a:solidFill>
                 <a:latin typeface="Calibri" pitchFamily="34" charset="0"/>
                 <a:ea typeface="Calibri" pitchFamily="34" charset="-122"/>
@@ -13629,7 +13675,7 @@
             <a:r>
               <a:rPr lang="en-US" sz="1200" dirty="0">
                 <a:solidFill>
-                  <a:srgbClr val="1A1A2E"/>
+                  <a:srgbClr val="2F3241"/>
                 </a:solidFill>
                 <a:latin typeface="Calibri" pitchFamily="34" charset="0"/>
                 <a:ea typeface="Calibri" pitchFamily="34" charset="-122"/>
@@ -13668,7 +13714,7 @@
             <a:r>
               <a:rPr lang="en-US" sz="1200" dirty="0">
                 <a:solidFill>
-                  <a:srgbClr val="1A1A2E"/>
+                  <a:srgbClr val="2F3241"/>
                 </a:solidFill>
                 <a:latin typeface="Calibri" pitchFamily="34" charset="0"/>
                 <a:ea typeface="Calibri" pitchFamily="34" charset="-122"/>
@@ -13730,7 +13776,7 @@
             <a:r>
               <a:rPr lang="en-US" sz="1200" b="1" dirty="0">
                 <a:solidFill>
-                  <a:srgbClr val="1A1A2E"/>
+                  <a:srgbClr val="2F3241"/>
                 </a:solidFill>
                 <a:latin typeface="Calibri" pitchFamily="34" charset="0"/>
                 <a:ea typeface="Calibri" pitchFamily="34" charset="-122"/>
@@ -13769,7 +13815,7 @@
             <a:r>
               <a:rPr lang="en-US" sz="1200" dirty="0">
                 <a:solidFill>
-                  <a:srgbClr val="1A1A2E"/>
+                  <a:srgbClr val="2F3241"/>
                 </a:solidFill>
                 <a:latin typeface="Calibri" pitchFamily="34" charset="0"/>
                 <a:ea typeface="Calibri" pitchFamily="34" charset="-122"/>
@@ -13808,7 +13854,7 @@
             <a:r>
               <a:rPr lang="en-US" sz="1200" dirty="0">
                 <a:solidFill>
-                  <a:srgbClr val="1A1A2E"/>
+                  <a:srgbClr val="2F3241"/>
                 </a:solidFill>
                 <a:latin typeface="Calibri" pitchFamily="34" charset="0"/>
                 <a:ea typeface="Calibri" pitchFamily="34" charset="-122"/>
@@ -13870,7 +13916,7 @@
             <a:r>
               <a:rPr lang="en-US" sz="1200" b="1" dirty="0">
                 <a:solidFill>
-                  <a:srgbClr val="1A1A2E"/>
+                  <a:srgbClr val="2F3241"/>
                 </a:solidFill>
                 <a:latin typeface="Calibri" pitchFamily="34" charset="0"/>
                 <a:ea typeface="Calibri" pitchFamily="34" charset="-122"/>
@@ -13909,7 +13955,7 @@
             <a:r>
               <a:rPr lang="en-US" sz="1200" dirty="0">
                 <a:solidFill>
-                  <a:srgbClr val="1A1A2E"/>
+                  <a:srgbClr val="2F3241"/>
                 </a:solidFill>
                 <a:latin typeface="Calibri" pitchFamily="34" charset="0"/>
                 <a:ea typeface="Calibri" pitchFamily="34" charset="-122"/>
@@ -13948,7 +13994,7 @@
             <a:r>
               <a:rPr lang="en-US" sz="1200" dirty="0">
                 <a:solidFill>
-                  <a:srgbClr val="1A1A2E"/>
+                  <a:srgbClr val="2F3241"/>
                 </a:solidFill>
                 <a:latin typeface="Calibri" pitchFamily="34" charset="0"/>
                 <a:ea typeface="Calibri" pitchFamily="34" charset="-122"/>
@@ -14010,7 +14056,7 @@
             <a:r>
               <a:rPr lang="en-US" sz="1200" b="1" dirty="0">
                 <a:solidFill>
-                  <a:srgbClr val="1A1A2E"/>
+                  <a:srgbClr val="2F3241"/>
                 </a:solidFill>
                 <a:latin typeface="Calibri" pitchFamily="34" charset="0"/>
                 <a:ea typeface="Calibri" pitchFamily="34" charset="-122"/>
@@ -14049,7 +14095,7 @@
             <a:r>
               <a:rPr lang="en-US" sz="1200" dirty="0">
                 <a:solidFill>
-                  <a:srgbClr val="1A1A2E"/>
+                  <a:srgbClr val="2F3241"/>
                 </a:solidFill>
                 <a:latin typeface="Calibri" pitchFamily="34" charset="0"/>
                 <a:ea typeface="Calibri" pitchFamily="34" charset="-122"/>
@@ -14088,7 +14134,7 @@
             <a:r>
               <a:rPr lang="en-US" sz="1200" dirty="0">
                 <a:solidFill>
-                  <a:srgbClr val="1A1A2E"/>
+                  <a:srgbClr val="2F3241"/>
                 </a:solidFill>
                 <a:latin typeface="Calibri" pitchFamily="34" charset="0"/>
                 <a:ea typeface="Calibri" pitchFamily="34" charset="-122"/>
@@ -14215,7 +14261,7 @@
     <p:bg>
       <p:bgPr>
         <a:solidFill>
-          <a:srgbClr val="1A1A2E"/>
+          <a:srgbClr val="2F3241"/>
         </a:solidFill>
       </p:bgPr>
     </p:bg>
@@ -14606,7 +14652,7 @@
             <a:r>
               <a:rPr lang="en-US" sz="2400" b="1" dirty="0">
                 <a:solidFill>
-                  <a:srgbClr val="1A1A2E"/>
+                  <a:srgbClr val="2F3241"/>
                 </a:solidFill>
                 <a:latin typeface="Calibri" pitchFamily="34" charset="0"/>
                 <a:ea typeface="Calibri" pitchFamily="34" charset="-122"/>
@@ -14623,7 +14669,7 @@
             <a:r>
               <a:rPr lang="en-US" sz="2400" dirty="0">
                 <a:solidFill>
-                  <a:srgbClr val="1A1A2E"/>
+                  <a:srgbClr val="2F3241"/>
                 </a:solidFill>
                 <a:latin typeface="Calibri" pitchFamily="34" charset="0"/>
                 <a:ea typeface="Calibri" pitchFamily="34" charset="-122"/>
@@ -14640,7 +14686,7 @@
             <a:r>
               <a:rPr lang="en-US" sz="2400" b="1" dirty="0">
                 <a:solidFill>
-                  <a:srgbClr val="1A1A2E"/>
+                  <a:srgbClr val="2F3241"/>
                 </a:solidFill>
                 <a:latin typeface="Calibri" pitchFamily="34" charset="0"/>
                 <a:ea typeface="Calibri" pitchFamily="34" charset="-122"/>
@@ -14657,7 +14703,7 @@
             <a:r>
               <a:rPr lang="en-US" sz="2400" dirty="0">
                 <a:solidFill>
-                  <a:srgbClr val="1A1A2E"/>
+                  <a:srgbClr val="2F3241"/>
                 </a:solidFill>
                 <a:latin typeface="Calibri" pitchFamily="34" charset="0"/>
                 <a:ea typeface="Calibri" pitchFamily="34" charset="-122"/>
@@ -14674,7 +14720,7 @@
             <a:r>
               <a:rPr lang="en-US" sz="2400" b="1" dirty="0">
                 <a:solidFill>
-                  <a:srgbClr val="1A1A2E"/>
+                  <a:srgbClr val="2F3241"/>
                 </a:solidFill>
                 <a:latin typeface="Calibri" pitchFamily="34" charset="0"/>
                 <a:ea typeface="Calibri" pitchFamily="34" charset="-122"/>
@@ -14691,7 +14737,7 @@
             <a:r>
               <a:rPr lang="en-US" sz="2400" dirty="0">
                 <a:solidFill>
-                  <a:srgbClr val="1A1A2E"/>
+                  <a:srgbClr val="2F3241"/>
                 </a:solidFill>
                 <a:latin typeface="Calibri" pitchFamily="34" charset="0"/>
                 <a:ea typeface="Calibri" pitchFamily="34" charset="-122"/>
@@ -14708,7 +14754,7 @@
             <a:r>
               <a:rPr lang="en-US" sz="2400" b="1" dirty="0">
                 <a:solidFill>
-                  <a:srgbClr val="1A1A2E"/>
+                  <a:srgbClr val="2F3241"/>
                 </a:solidFill>
                 <a:latin typeface="Calibri" pitchFamily="34" charset="0"/>
                 <a:ea typeface="Calibri" pitchFamily="34" charset="-122"/>
@@ -14725,7 +14771,7 @@
             <a:r>
               <a:rPr lang="en-US" sz="2400" dirty="0">
                 <a:solidFill>
-                  <a:srgbClr val="1A1A2E"/>
+                  <a:srgbClr val="2F3241"/>
                 </a:solidFill>
                 <a:latin typeface="Calibri" pitchFamily="34" charset="0"/>
                 <a:ea typeface="Calibri" pitchFamily="34" charset="-122"/>
@@ -14742,7 +14788,7 @@
             <a:r>
               <a:rPr lang="en-US" sz="2400" b="1" dirty="0">
                 <a:solidFill>
-                  <a:srgbClr val="1A1A2E"/>
+                  <a:srgbClr val="2F3241"/>
                 </a:solidFill>
                 <a:latin typeface="Calibri" pitchFamily="34" charset="0"/>
                 <a:ea typeface="Calibri" pitchFamily="34" charset="-122"/>
@@ -14759,7 +14805,7 @@
             <a:r>
               <a:rPr lang="en-US" sz="2400" dirty="0">
                 <a:solidFill>
-                  <a:srgbClr val="1A1A2E"/>
+                  <a:srgbClr val="2F3241"/>
                 </a:solidFill>
                 <a:latin typeface="Calibri" pitchFamily="34" charset="0"/>
                 <a:ea typeface="Calibri" pitchFamily="34" charset="-122"/>
@@ -14776,7 +14822,7 @@
             <a:r>
               <a:rPr lang="en-US" sz="2400" b="1" dirty="0">
                 <a:solidFill>
-                  <a:srgbClr val="1A1A2E"/>
+                  <a:srgbClr val="2F3241"/>
                 </a:solidFill>
                 <a:latin typeface="Calibri" pitchFamily="34" charset="0"/>
                 <a:ea typeface="Calibri" pitchFamily="34" charset="-122"/>
@@ -14793,7 +14839,7 @@
             <a:r>
               <a:rPr lang="en-US" sz="2400" dirty="0">
                 <a:solidFill>
-                  <a:srgbClr val="1A1A2E"/>
+                  <a:srgbClr val="2F3241"/>
                 </a:solidFill>
                 <a:latin typeface="Calibri" pitchFamily="34" charset="0"/>
                 <a:ea typeface="Calibri" pitchFamily="34" charset="-122"/>
@@ -14810,7 +14856,7 @@
             <a:r>
               <a:rPr lang="en-US" sz="2400" b="1" dirty="0">
                 <a:solidFill>
-                  <a:srgbClr val="C22299"/>
+                  <a:srgbClr val="C43C96"/>
                 </a:solidFill>
                 <a:latin typeface="Calibri" pitchFamily="34" charset="0"/>
                 <a:ea typeface="Calibri" pitchFamily="34" charset="-122"/>
@@ -14827,7 +14873,7 @@
             <a:r>
               <a:rPr lang="en-US" sz="2400" dirty="0">
                 <a:solidFill>
-                  <a:srgbClr val="1A1A2E"/>
+                  <a:srgbClr val="2F3241"/>
                 </a:solidFill>
                 <a:latin typeface="Calibri" pitchFamily="34" charset="0"/>
                 <a:ea typeface="Calibri" pitchFamily="34" charset="-122"/>
@@ -15060,7 +15106,7 @@
             <a:r>
               <a:rPr lang="en-US" sz="2200" b="1" spc="-30" kern="0" dirty="0">
                 <a:solidFill>
-                  <a:srgbClr val="1A1A2E"/>
+                  <a:srgbClr val="2F3241"/>
                 </a:solidFill>
                 <a:latin typeface="Trebuchet MS" pitchFamily="34" charset="0"/>
                 <a:ea typeface="Trebuchet MS" pitchFamily="34" charset="-122"/>
@@ -15080,7 +15126,7 @@
             <a:r>
               <a:rPr lang="en-US" sz="2200" b="1" spc="-30" kern="0" dirty="0">
                 <a:solidFill>
-                  <a:srgbClr val="1A1A2E"/>
+                  <a:srgbClr val="2F3241"/>
                 </a:solidFill>
                 <a:latin typeface="Trebuchet MS" pitchFamily="34" charset="0"/>
                 <a:ea typeface="Trebuchet MS" pitchFamily="34" charset="-122"/>
@@ -15100,7 +15146,7 @@
             <a:r>
               <a:rPr lang="en-US" sz="2200" b="1" spc="-30" kern="0" dirty="0">
                 <a:solidFill>
-                  <a:srgbClr val="1A1A2E"/>
+                  <a:srgbClr val="2F3241"/>
                 </a:solidFill>
                 <a:latin typeface="Trebuchet MS" pitchFamily="34" charset="0"/>
                 <a:ea typeface="Trebuchet MS" pitchFamily="34" charset="-122"/>
@@ -15120,7 +15166,7 @@
             <a:r>
               <a:rPr lang="en-US" sz="2200" b="1" spc="-30" kern="0" dirty="0">
                 <a:solidFill>
-                  <a:srgbClr val="1A1A2E"/>
+                  <a:srgbClr val="2F3241"/>
                 </a:solidFill>
                 <a:latin typeface="Trebuchet MS" pitchFamily="34" charset="0"/>
                 <a:ea typeface="Trebuchet MS" pitchFamily="34" charset="-122"/>
@@ -15140,7 +15186,7 @@
             <a:r>
               <a:rPr lang="en-US" sz="2200" b="1" spc="-30" kern="0" dirty="0">
                 <a:solidFill>
-                  <a:srgbClr val="1A1A2E"/>
+                  <a:srgbClr val="2F3241"/>
                 </a:solidFill>
                 <a:latin typeface="Trebuchet MS" pitchFamily="34" charset="0"/>
                 <a:ea typeface="Trebuchet MS" pitchFamily="34" charset="-122"/>
@@ -15221,7 +15267,7 @@
             <a:r>
               <a:rPr lang="en-US" sz="1300" dirty="0">
                 <a:solidFill>
-                  <a:srgbClr val="1A1A2E"/>
+                  <a:srgbClr val="2F3241"/>
                 </a:solidFill>
                 <a:latin typeface="Calibri" pitchFamily="34" charset="0"/>
                 <a:ea typeface="Calibri" pitchFamily="34" charset="-122"/>
@@ -15283,7 +15329,7 @@
             <a:r>
               <a:rPr lang="en-US" sz="1000" b="1" spc="400" kern="0" dirty="0">
                 <a:solidFill>
-                  <a:srgbClr val="C22299"/>
+                  <a:srgbClr val="C43C96"/>
                 </a:solidFill>
                 <a:latin typeface="Calibri" pitchFamily="34" charset="0"/>
                 <a:ea typeface="Calibri" pitchFamily="34" charset="-122"/>
@@ -15325,7 +15371,7 @@
             <a:r>
               <a:rPr lang="en-US" sz="1200" dirty="0">
                 <a:solidFill>
-                  <a:srgbClr val="1A1A2E"/>
+                  <a:srgbClr val="2F3241"/>
                 </a:solidFill>
                 <a:latin typeface="Calibri" pitchFamily="34" charset="0"/>
                 <a:ea typeface="Calibri" pitchFamily="34" charset="-122"/>
@@ -15429,7 +15475,7 @@
     <p:bg>
       <p:bgPr>
         <a:solidFill>
-          <a:srgbClr val="1A1A2E"/>
+          <a:srgbClr val="2F3241"/>
         </a:solidFill>
       </p:bgPr>
     </p:bg>
@@ -15802,7 +15848,7 @@
             <a:r>
               <a:rPr lang="en-US" sz="22000" b="1" spc="-800" kern="0" dirty="0">
                 <a:solidFill>
-                  <a:srgbClr val="1A1A2E"/>
+                  <a:srgbClr val="2F3241"/>
                 </a:solidFill>
                 <a:latin typeface="Trebuchet MS" pitchFamily="34" charset="0"/>
                 <a:ea typeface="Trebuchet MS" pitchFamily="34" charset="-122"/>
@@ -15841,7 +15887,7 @@
             <a:r>
               <a:rPr lang="en-US" sz="2600" spc="-50" kern="0" dirty="0">
                 <a:solidFill>
-                  <a:srgbClr val="1A1A2E"/>
+                  <a:srgbClr val="2F3241"/>
                 </a:solidFill>
                 <a:latin typeface="Trebuchet MS" pitchFamily="34" charset="0"/>
                 <a:ea typeface="Trebuchet MS" pitchFamily="34" charset="-122"/>
@@ -15900,7 +15946,7 @@
             <a:r>
               <a:rPr lang="en-US" sz="1500" b="1" dirty="0">
                 <a:solidFill>
-                  <a:srgbClr val="1A1A2E"/>
+                  <a:srgbClr val="2F3241"/>
                 </a:solidFill>
                 <a:latin typeface="Calibri" pitchFamily="34" charset="0"/>
                 <a:ea typeface="Calibri" pitchFamily="34" charset="-122"/>
@@ -15934,7 +15980,7 @@
             <a:r>
               <a:rPr lang="en-US" sz="1500" b="1" dirty="0">
                 <a:solidFill>
-                  <a:srgbClr val="1A1A2E"/>
+                  <a:srgbClr val="2F3241"/>
                 </a:solidFill>
                 <a:latin typeface="Calibri" pitchFamily="34" charset="0"/>
                 <a:ea typeface="Calibri" pitchFamily="34" charset="-122"/>
@@ -15968,7 +16014,7 @@
             <a:r>
               <a:rPr lang="en-US" sz="1500" b="1" dirty="0">
                 <a:solidFill>
-                  <a:srgbClr val="1A1A2E"/>
+                  <a:srgbClr val="2F3241"/>
                 </a:solidFill>
                 <a:latin typeface="Calibri" pitchFamily="34" charset="0"/>
                 <a:ea typeface="Calibri" pitchFamily="34" charset="-122"/>
@@ -16173,7 +16219,7 @@
             <a:r>
               <a:rPr lang="en-US" sz="3600" b="1" spc="-50" kern="0" dirty="0">
                 <a:solidFill>
-                  <a:srgbClr val="1A1A2E"/>
+                  <a:srgbClr val="2F3241"/>
                 </a:solidFill>
                 <a:latin typeface="Trebuchet MS" pitchFamily="34" charset="0"/>
                 <a:ea typeface="Trebuchet MS" pitchFamily="34" charset="-122"/>
@@ -16254,7 +16300,7 @@
             <a:r>
               <a:rPr lang="en-US" sz="1600" dirty="0">
                 <a:solidFill>
-                  <a:srgbClr val="1A1A2E"/>
+                  <a:srgbClr val="2F3241"/>
                 </a:solidFill>
                 <a:latin typeface="Calibri" pitchFamily="34" charset="0"/>
                 <a:ea typeface="Calibri" pitchFamily="34" charset="-122"/>
@@ -16335,7 +16381,7 @@
             <a:r>
               <a:rPr lang="en-US" sz="1500" dirty="0">
                 <a:solidFill>
-                  <a:srgbClr val="1A1A2E"/>
+                  <a:srgbClr val="2F3241"/>
                 </a:solidFill>
                 <a:latin typeface="Calibri" pitchFamily="34" charset="0"/>
                 <a:ea typeface="Calibri" pitchFamily="34" charset="-122"/>
@@ -16416,7 +16462,7 @@
             <a:r>
               <a:rPr lang="en-US" sz="1500" dirty="0">
                 <a:solidFill>
-                  <a:srgbClr val="1A1A2E"/>
+                  <a:srgbClr val="2F3241"/>
                 </a:solidFill>
                 <a:latin typeface="Calibri" pitchFamily="34" charset="0"/>
                 <a:ea typeface="Calibri" pitchFamily="34" charset="-122"/>
@@ -16497,7 +16543,7 @@
             <a:r>
               <a:rPr lang="en-US" sz="1400" dirty="0">
                 <a:solidFill>
-                  <a:srgbClr val="1A1A2E"/>
+                  <a:srgbClr val="2F3241"/>
                 </a:solidFill>
                 <a:latin typeface="Calibri" pitchFamily="34" charset="0"/>
                 <a:ea typeface="Calibri" pitchFamily="34" charset="-122"/>
@@ -16649,7 +16695,7 @@
             <a:r>
               <a:rPr lang="en-US" sz="4000" b="1" spc="-80" kern="0" dirty="0">
                 <a:solidFill>
-                  <a:srgbClr val="1A1A2E"/>
+                  <a:srgbClr val="2F3241"/>
                 </a:solidFill>
                 <a:latin typeface="Trebuchet MS" pitchFamily="34" charset="0"/>
                 <a:ea typeface="Trebuchet MS" pitchFamily="34" charset="-122"/>
@@ -16669,7 +16715,7 @@
             <a:r>
               <a:rPr lang="en-US" sz="4000" b="1" spc="-80" kern="0" dirty="0">
                 <a:solidFill>
-                  <a:srgbClr val="1A1A2E"/>
+                  <a:srgbClr val="2F3241"/>
                 </a:solidFill>
                 <a:latin typeface="Trebuchet MS" pitchFamily="34" charset="0"/>
                 <a:ea typeface="Trebuchet MS" pitchFamily="34" charset="-122"/>
@@ -16689,7 +16735,7 @@
             <a:r>
               <a:rPr lang="en-US" sz="4000" b="1" spc="-80" kern="0" dirty="0">
                 <a:solidFill>
-                  <a:srgbClr val="1A1A2E"/>
+                  <a:srgbClr val="2F3241"/>
                 </a:solidFill>
                 <a:latin typeface="Trebuchet MS" pitchFamily="34" charset="0"/>
                 <a:ea typeface="Trebuchet MS" pitchFamily="34" charset="-122"/>
@@ -16709,7 +16755,7 @@
             <a:r>
               <a:rPr lang="en-US" sz="4000" b="1" spc="-80" kern="0" dirty="0">
                 <a:solidFill>
-                  <a:srgbClr val="1A1A2E"/>
+                  <a:srgbClr val="2F3241"/>
                 </a:solidFill>
                 <a:latin typeface="Trebuchet MS" pitchFamily="34" charset="0"/>
                 <a:ea typeface="Trebuchet MS" pitchFamily="34" charset="-122"/>
@@ -16813,7 +16859,7 @@
             <a:r>
               <a:rPr lang="en-US" sz="1500" dirty="0">
                 <a:solidFill>
-                  <a:srgbClr val="1A1A2E"/>
+                  <a:srgbClr val="2F3241"/>
                 </a:solidFill>
                 <a:latin typeface="Calibri" pitchFamily="34" charset="0"/>
                 <a:ea typeface="Calibri" pitchFamily="34" charset="-122"/>
@@ -16894,7 +16940,7 @@
             <a:r>
               <a:rPr lang="en-US" sz="1500" dirty="0">
                 <a:solidFill>
-                  <a:srgbClr val="1A1A2E"/>
+                  <a:srgbClr val="2F3241"/>
                 </a:solidFill>
                 <a:latin typeface="Calibri" pitchFamily="34" charset="0"/>
                 <a:ea typeface="Calibri" pitchFamily="34" charset="-122"/>
@@ -17085,7 +17131,7 @@
             <a:r>
               <a:rPr lang="en-US" sz="3400" spc="-50" kern="0" dirty="0">
                 <a:solidFill>
-                  <a:srgbClr val="1A1A2E"/>
+                  <a:srgbClr val="2F3241"/>
                 </a:solidFill>
                 <a:latin typeface="Trebuchet MS" pitchFamily="34" charset="0"/>
                 <a:ea typeface="Trebuchet MS" pitchFamily="34" charset="-122"/>
@@ -17102,7 +17148,7 @@
             <a:r>
               <a:rPr lang="en-US" sz="3400" b="1" spc="-50" kern="0" dirty="0">
                 <a:solidFill>
-                  <a:srgbClr val="C22299"/>
+                  <a:srgbClr val="C43C96"/>
                 </a:solidFill>
                 <a:latin typeface="Trebuchet MS" pitchFamily="34" charset="0"/>
                 <a:ea typeface="Trebuchet MS" pitchFamily="34" charset="-122"/>
@@ -17119,7 +17165,7 @@
             <a:r>
               <a:rPr lang="en-US" sz="3400" spc="-50" kern="0" dirty="0">
                 <a:solidFill>
-                  <a:srgbClr val="1A1A2E"/>
+                  <a:srgbClr val="2F3241"/>
                 </a:solidFill>
                 <a:latin typeface="Trebuchet MS" pitchFamily="34" charset="0"/>
                 <a:ea typeface="Trebuchet MS" pitchFamily="34" charset="-122"/>
@@ -17153,7 +17199,7 @@
             <a:r>
               <a:rPr lang="en-US" sz="3400" spc="-50" kern="0" dirty="0">
                 <a:solidFill>
-                  <a:srgbClr val="1A1A2E"/>
+                  <a:srgbClr val="2F3241"/>
                 </a:solidFill>
                 <a:latin typeface="Trebuchet MS" pitchFamily="34" charset="0"/>
                 <a:ea typeface="Trebuchet MS" pitchFamily="34" charset="-122"/>
@@ -17187,7 +17233,7 @@
             <a:r>
               <a:rPr lang="en-US" sz="3400" spc="-50" kern="0" dirty="0">
                 <a:solidFill>
-                  <a:srgbClr val="1A1A2E"/>
+                  <a:srgbClr val="2F3241"/>
                 </a:solidFill>
                 <a:latin typeface="Trebuchet MS" pitchFamily="34" charset="0"/>
                 <a:ea typeface="Trebuchet MS" pitchFamily="34" charset="-122"/>
@@ -17221,7 +17267,7 @@
             <a:r>
               <a:rPr lang="en-US" sz="3400" spc="-50" kern="0" dirty="0">
                 <a:solidFill>
-                  <a:srgbClr val="1A1A2E"/>
+                  <a:srgbClr val="2F3241"/>
                 </a:solidFill>
                 <a:latin typeface="Trebuchet MS" pitchFamily="34" charset="0"/>
                 <a:ea typeface="Trebuchet MS" pitchFamily="34" charset="-122"/>
@@ -17255,7 +17301,7 @@
             <a:r>
               <a:rPr lang="en-US" sz="3400" spc="-50" kern="0" dirty="0">
                 <a:solidFill>
-                  <a:srgbClr val="1A1A2E"/>
+                  <a:srgbClr val="2F3241"/>
                 </a:solidFill>
                 <a:latin typeface="Trebuchet MS" pitchFamily="34" charset="0"/>
                 <a:ea typeface="Trebuchet MS" pitchFamily="34" charset="-122"/>
@@ -17404,7 +17450,7 @@
             <a:r>
               <a:rPr lang="en-US" sz="2800" b="1" spc="-50" kern="0" dirty="0">
                 <a:solidFill>
-                  <a:srgbClr val="1A1A2E"/>
+                  <a:srgbClr val="2F3241"/>
                 </a:solidFill>
                 <a:latin typeface="Trebuchet MS" pitchFamily="34" charset="0"/>
                 <a:ea typeface="Trebuchet MS" pitchFamily="34" charset="-122"/>
@@ -17524,7 +17570,7 @@
             <a:r>
               <a:rPr lang="en-US" sz="1400" dirty="0">
                 <a:solidFill>
-                  <a:srgbClr val="1A1A2E"/>
+                  <a:srgbClr val="2F3241"/>
                 </a:solidFill>
                 <a:latin typeface="Calibri" pitchFamily="34" charset="0"/>
                 <a:ea typeface="Calibri" pitchFamily="34" charset="-122"/>
@@ -17563,7 +17609,7 @@
             <a:r>
               <a:rPr lang="en-US" sz="1000" b="1" spc="400" kern="0" dirty="0">
                 <a:solidFill>
-                  <a:srgbClr val="C22299"/>
+                  <a:srgbClr val="C43C96"/>
                 </a:solidFill>
                 <a:latin typeface="Calibri" pitchFamily="34" charset="0"/>
                 <a:ea typeface="Calibri" pitchFamily="34" charset="-122"/>
@@ -17605,7 +17651,7 @@
             <a:r>
               <a:rPr lang="en-US" sz="1400" dirty="0">
                 <a:solidFill>
-                  <a:srgbClr val="1A1A2E"/>
+                  <a:srgbClr val="2F3241"/>
                 </a:solidFill>
                 <a:latin typeface="Calibri" pitchFamily="34" charset="0"/>
                 <a:ea typeface="Calibri" pitchFamily="34" charset="-122"/>
@@ -17816,7 +17862,7 @@
             <a:r>
               <a:rPr lang="en-US" sz="3000" b="1" spc="-50" kern="0" dirty="0">
                 <a:solidFill>
-                  <a:srgbClr val="1A1A2E"/>
+                  <a:srgbClr val="2F3241"/>
                 </a:solidFill>
                 <a:latin typeface="Trebuchet MS" pitchFamily="34" charset="0"/>
                 <a:ea typeface="Trebuchet MS" pitchFamily="34" charset="-122"/>
@@ -17878,7 +17924,7 @@
             <a:r>
               <a:rPr lang="en-US" sz="3000" b="1" spc="-80" kern="0" dirty="0">
                 <a:solidFill>
-                  <a:srgbClr val="1A1A2E"/>
+                  <a:srgbClr val="2F3241"/>
                 </a:solidFill>
                 <a:latin typeface="Trebuchet MS" pitchFamily="34" charset="0"/>
                 <a:ea typeface="Trebuchet MS" pitchFamily="34" charset="-122"/>
@@ -17979,7 +18025,7 @@
             <a:r>
               <a:rPr lang="en-US" sz="3000" b="1" spc="-80" kern="0" dirty="0">
                 <a:solidFill>
-                  <a:srgbClr val="1A1A2E"/>
+                  <a:srgbClr val="2F3241"/>
                 </a:solidFill>
                 <a:latin typeface="Trebuchet MS" pitchFamily="34" charset="0"/>
                 <a:ea typeface="Trebuchet MS" pitchFamily="34" charset="-122"/>
@@ -18080,7 +18126,7 @@
             <a:r>
               <a:rPr lang="en-US" sz="3000" b="1" spc="-80" kern="0" dirty="0">
                 <a:solidFill>
-                  <a:srgbClr val="1A1A2E"/>
+                  <a:srgbClr val="2F3241"/>
                 </a:solidFill>
                 <a:latin typeface="Trebuchet MS" pitchFamily="34" charset="0"/>
                 <a:ea typeface="Trebuchet MS" pitchFamily="34" charset="-122"/>
@@ -18181,7 +18227,7 @@
             <a:r>
               <a:rPr lang="en-US" sz="3000" b="1" spc="-80" kern="0" dirty="0">
                 <a:solidFill>
-                  <a:srgbClr val="1A1A2E"/>
+                  <a:srgbClr val="2F3241"/>
                 </a:solidFill>
                 <a:latin typeface="Trebuchet MS" pitchFamily="34" charset="0"/>
                 <a:ea typeface="Trebuchet MS" pitchFamily="34" charset="-122"/>
@@ -18282,7 +18328,7 @@
             <a:r>
               <a:rPr lang="en-US" sz="3000" b="1" spc="-80" kern="0" dirty="0">
                 <a:solidFill>
-                  <a:srgbClr val="1A1A2E"/>
+                  <a:srgbClr val="2F3241"/>
                 </a:solidFill>
                 <a:latin typeface="Trebuchet MS" pitchFamily="34" charset="0"/>
                 <a:ea typeface="Trebuchet MS" pitchFamily="34" charset="-122"/>
@@ -18509,7 +18555,7 @@
             <a:r>
               <a:rPr lang="en-US" sz="2200" b="1" spc="-30" kern="0" dirty="0">
                 <a:solidFill>
-                  <a:srgbClr val="1A1A2E"/>
+                  <a:srgbClr val="2F3241"/>
                 </a:solidFill>
                 <a:latin typeface="Trebuchet MS" pitchFamily="34" charset="0"/>
                 <a:ea typeface="Trebuchet MS" pitchFamily="34" charset="-122"/>
@@ -18548,7 +18594,7 @@
             <a:r>
               <a:rPr lang="en-US" sz="1300" i="1" dirty="0">
                 <a:solidFill>
-                  <a:srgbClr val="C22299"/>
+                  <a:srgbClr val="C43C96"/>
                 </a:solidFill>
                 <a:latin typeface="Calibri" pitchFamily="34" charset="0"/>
                 <a:ea typeface="Calibri" pitchFamily="34" charset="-122"/>
@@ -18590,7 +18636,7 @@
             <a:r>
               <a:rPr lang="en-US" sz="1300" dirty="0">
                 <a:solidFill>
-                  <a:srgbClr val="1A1A2E"/>
+                  <a:srgbClr val="2F3241"/>
                 </a:solidFill>
                 <a:latin typeface="Calibri" pitchFamily="34" charset="0"/>
                 <a:ea typeface="Calibri" pitchFamily="34" charset="-122"/>
@@ -18697,7 +18743,7 @@
             <a:r>
               <a:rPr lang="en-US" sz="2800" spc="-50" kern="0" dirty="0">
                 <a:solidFill>
-                  <a:srgbClr val="1A1A2E"/>
+                  <a:srgbClr val="2F3241"/>
                 </a:solidFill>
                 <a:latin typeface="Trebuchet MS" pitchFamily="34" charset="0"/>
                 <a:ea typeface="Trebuchet MS" pitchFamily="34" charset="-122"/>

</xml_diff>